<commit_message>
Replace Pingshan slide photo with teacher programme group portrait and refresh English downloads
</commit_message>
<xml_diff>
--- a/teacher-agent-creators-10min/downloads/UNESCO_Teacher_AI_Agents_EN.pptx
+++ b/teacher-agent-creators-10min/downloads/UNESCO_Teacher_AI_Agents_EN.pptx
@@ -2,29 +2,29 @@
 <file path=ppt/presentation.xml><?xml version="1.0" encoding="utf-8"?>
 <p:presentation xmlns:p="http://schemas.openxmlformats.org/presentationml/2006/main">
   <p:sldMasterIdLst>
-    <p:sldMasterId xmlns:r="http://schemas.openxmlformats.org/officeDocument/2006/relationships" id="2147483648" r:id="R48405a69e4614717"/>
+    <p:sldMasterId xmlns:r="http://schemas.openxmlformats.org/officeDocument/2006/relationships" id="2147483648" r:id="Rb940c4e8249847d6"/>
   </p:sldMasterIdLst>
   <p:notesMasterIdLst>
-    <p:notesMasterId xmlns:r="http://schemas.openxmlformats.org/officeDocument/2006/relationships" r:id="R9c749ed487924e87"/>
+    <p:notesMasterId xmlns:r="http://schemas.openxmlformats.org/officeDocument/2006/relationships" r:id="R6f6e17a342d445bd"/>
   </p:notesMasterIdLst>
   <p:sldIdLst>
-    <p:sldId xmlns:r="http://schemas.openxmlformats.org/officeDocument/2006/relationships" id="256" r:id="R5821a14114fd4370"/>
-    <p:sldId xmlns:r="http://schemas.openxmlformats.org/officeDocument/2006/relationships" id="257" r:id="Rf5281db394dc46e4"/>
-    <p:sldId xmlns:r="http://schemas.openxmlformats.org/officeDocument/2006/relationships" id="258" r:id="Rd16e6d804c784ef5"/>
-    <p:sldId xmlns:r="http://schemas.openxmlformats.org/officeDocument/2006/relationships" id="259" r:id="Re3c3f8acf6d844c8"/>
-    <p:sldId xmlns:r="http://schemas.openxmlformats.org/officeDocument/2006/relationships" id="260" r:id="Rb0f689da1fbb4c46"/>
-    <p:sldId xmlns:r="http://schemas.openxmlformats.org/officeDocument/2006/relationships" id="261" r:id="R314bbdeab3ff41f4"/>
-    <p:sldId xmlns:r="http://schemas.openxmlformats.org/officeDocument/2006/relationships" id="262" r:id="R554e3e3d12684621"/>
-    <p:sldId xmlns:r="http://schemas.openxmlformats.org/officeDocument/2006/relationships" id="263" r:id="R66668b0f64e147d5"/>
-    <p:sldId xmlns:r="http://schemas.openxmlformats.org/officeDocument/2006/relationships" id="264" r:id="R7564a762fa184f3d"/>
-    <p:sldId xmlns:r="http://schemas.openxmlformats.org/officeDocument/2006/relationships" id="265" r:id="R45c74a90bebc4e69"/>
-    <p:sldId xmlns:r="http://schemas.openxmlformats.org/officeDocument/2006/relationships" id="266" r:id="R61a40ada6dbe4506"/>
-    <p:sldId xmlns:r="http://schemas.openxmlformats.org/officeDocument/2006/relationships" id="267" r:id="R8ea32a308c8f46dd"/>
-    <p:sldId xmlns:r="http://schemas.openxmlformats.org/officeDocument/2006/relationships" id="268" r:id="Rab57e6024a3047f2"/>
-    <p:sldId xmlns:r="http://schemas.openxmlformats.org/officeDocument/2006/relationships" id="269" r:id="R3d596b2512a94a0c"/>
-    <p:sldId xmlns:r="http://schemas.openxmlformats.org/officeDocument/2006/relationships" id="270" r:id="Rfdc6b0bf9cc14f86"/>
-    <p:sldId xmlns:r="http://schemas.openxmlformats.org/officeDocument/2006/relationships" id="271" r:id="Rcbde2bce756c480e"/>
-    <p:sldId xmlns:r="http://schemas.openxmlformats.org/officeDocument/2006/relationships" id="272" r:id="R2f90c78b346243a4"/>
+    <p:sldId xmlns:r="http://schemas.openxmlformats.org/officeDocument/2006/relationships" id="256" r:id="R64aa498d64614160"/>
+    <p:sldId xmlns:r="http://schemas.openxmlformats.org/officeDocument/2006/relationships" id="257" r:id="Raddb9b1d4d8b4429"/>
+    <p:sldId xmlns:r="http://schemas.openxmlformats.org/officeDocument/2006/relationships" id="258" r:id="R105ac38bb6a44633"/>
+    <p:sldId xmlns:r="http://schemas.openxmlformats.org/officeDocument/2006/relationships" id="259" r:id="R3876385f342648fa"/>
+    <p:sldId xmlns:r="http://schemas.openxmlformats.org/officeDocument/2006/relationships" id="260" r:id="Rb1d9b4445e0948e1"/>
+    <p:sldId xmlns:r="http://schemas.openxmlformats.org/officeDocument/2006/relationships" id="261" r:id="R9222942195584741"/>
+    <p:sldId xmlns:r="http://schemas.openxmlformats.org/officeDocument/2006/relationships" id="262" r:id="Rf002ae3935d445c3"/>
+    <p:sldId xmlns:r="http://schemas.openxmlformats.org/officeDocument/2006/relationships" id="263" r:id="Ref83ad029ac84c16"/>
+    <p:sldId xmlns:r="http://schemas.openxmlformats.org/officeDocument/2006/relationships" id="264" r:id="R6ddf4903549b4b4c"/>
+    <p:sldId xmlns:r="http://schemas.openxmlformats.org/officeDocument/2006/relationships" id="265" r:id="Rec3eccd1183d4485"/>
+    <p:sldId xmlns:r="http://schemas.openxmlformats.org/officeDocument/2006/relationships" id="266" r:id="R3375f245111c41c0"/>
+    <p:sldId xmlns:r="http://schemas.openxmlformats.org/officeDocument/2006/relationships" id="267" r:id="Rb929e2be0d3445d2"/>
+    <p:sldId xmlns:r="http://schemas.openxmlformats.org/officeDocument/2006/relationships" id="268" r:id="R14693c7da80842ae"/>
+    <p:sldId xmlns:r="http://schemas.openxmlformats.org/officeDocument/2006/relationships" id="269" r:id="R799c2c5cd0eb4927"/>
+    <p:sldId xmlns:r="http://schemas.openxmlformats.org/officeDocument/2006/relationships" id="270" r:id="R8c720fe39d3e4a0a"/>
+    <p:sldId xmlns:r="http://schemas.openxmlformats.org/officeDocument/2006/relationships" id="271" r:id="R69df1b949b9447c0"/>
+    <p:sldId xmlns:r="http://schemas.openxmlformats.org/officeDocument/2006/relationships" id="272" r:id="R2e9976c50d3e4aa3"/>
   </p:sldIdLst>
   <p:sldSz cx="12192000" cy="6858000"/>
   <p:notesSz cx="6858000" cy="9144000"/>
@@ -1993,7 +1993,7 @@
           </a:p>
           <a:p xmlns:a="http://schemas.openxmlformats.org/drawingml/2006/main">
             <a:r>
-              <a:t>Photo: pingshan-training.webp from the original presentation, programme context. It shows teachers discussing designs. The classroom image on slide 2 is the supplied Pingshan case.</a:t>
+              <a:t>Photo: IMG_3939.png supplied by the presenter in this conversation, showing the group at the second Pingshan primary and secondary school AI pioneer teacher professional-learning programme. The on-site banner identifies the Pingshan programme. The photo illustrates participation in practice; it does not establish the size of the research sample or identify a particular research cohort. Used as pingshan-teacher-group.webp. The classroom image on slide 2 remains the supplied Pingshan English case.</a:t>
             </a:r>
           </a:p>
         </p:txBody>
@@ -2411,7 +2411,7 @@
   </p:cSld>
   <p:clrMap bg1="lt1" tx1="dk1" bg2="lt2" tx2="dk2" accent1="accent1" accent2="accent2" accent3="accent3" accent4="accent4" accent5="accent5" accent6="accent6" hlink="hlink" folHlink="folHlink"/>
   <p:sldLayoutIdLst>
-    <p:sldLayoutId xmlns:r="http://schemas.openxmlformats.org/officeDocument/2006/relationships" id="2147483649" r:id="Rf6ea66b2064d4ba9"/>
+    <p:sldLayoutId xmlns:r="http://schemas.openxmlformats.org/officeDocument/2006/relationships" id="2147483649" r:id="R845769e275cc4cbd"/>
   </p:sldLayoutIdLst>
   <p:txStyles>
     <p:titleStyle>
@@ -2959,14 +2959,14 @@
       </p:grpSpPr>
       <p:pic>
         <p:nvPicPr>
-          <p:cNvPr id="12" name=""/>
+          <p:cNvPr id="14" name=""/>
           <p:cNvPicPr>
             <a:picLocks xmlns:a="http://schemas.openxmlformats.org/drawingml/2006/main" noChangeAspect="1"/>
           </p:cNvPicPr>
           <p:nvPr/>
         </p:nvPicPr>
         <p:blipFill>
-          <a:blip xmlns:r="http://schemas.openxmlformats.org/officeDocument/2006/relationships" xmlns:a="http://schemas.openxmlformats.org/drawingml/2006/main" r:embed="R79daf29065f6405e"/>
+          <a:blip xmlns:r="http://schemas.openxmlformats.org/officeDocument/2006/relationships" xmlns:a="http://schemas.openxmlformats.org/drawingml/2006/main" r:embed="Rba5cd2d33c88465c"/>
           <a:srcRect xmlns:a="http://schemas.openxmlformats.org/drawingml/2006/main" l="12154" t="0" r="12154" b="0"/>
           <a:stretch xmlns:a="http://schemas.openxmlformats.org/drawingml/2006/main">
             <a:fillRect l="0" t="0" r="0" b="0"/>
@@ -2984,14 +2984,14 @@
       </p:pic>
       <p:pic>
         <p:nvPicPr>
-          <p:cNvPr id="13" name=""/>
+          <p:cNvPr id="15" name=""/>
           <p:cNvPicPr>
             <a:picLocks xmlns:a="http://schemas.openxmlformats.org/drawingml/2006/main" noChangeAspect="1"/>
           </p:cNvPicPr>
           <p:nvPr/>
         </p:nvPicPr>
         <p:blipFill>
-          <a:blip xmlns:r="http://schemas.openxmlformats.org/officeDocument/2006/relationships" xmlns:a="http://schemas.openxmlformats.org/drawingml/2006/main" r:embed="R411ae20a6fdc4b75"/>
+          <a:blip xmlns:r="http://schemas.openxmlformats.org/officeDocument/2006/relationships" xmlns:a="http://schemas.openxmlformats.org/drawingml/2006/main" r:embed="R246e2e5f812d468d"/>
           <a:stretch xmlns:a="http://schemas.openxmlformats.org/drawingml/2006/main"/>
         </p:blipFill>
         <p:spPr>
@@ -5254,14 +5254,14 @@
       </p:sp>
       <p:pic>
         <p:nvPicPr>
-          <p:cNvPr id="21" name=""/>
+          <p:cNvPr id="23" name=""/>
           <p:cNvPicPr>
             <a:picLocks xmlns:a="http://schemas.openxmlformats.org/drawingml/2006/main" noChangeAspect="1"/>
           </p:cNvPicPr>
           <p:nvPr/>
         </p:nvPicPr>
         <p:blipFill>
-          <a:blip xmlns:r="http://schemas.openxmlformats.org/officeDocument/2006/relationships" xmlns:a="http://schemas.openxmlformats.org/drawingml/2006/main" r:embed="R70713cf0943d4707"/>
+          <a:blip xmlns:r="http://schemas.openxmlformats.org/officeDocument/2006/relationships" xmlns:a="http://schemas.openxmlformats.org/drawingml/2006/main" r:embed="Ra241bff2abe24fee"/>
           <a:stretch xmlns:a="http://schemas.openxmlformats.org/drawingml/2006/main"/>
         </p:blipFill>
         <p:spPr>
@@ -5945,14 +5945,14 @@
       </p:sp>
       <p:pic>
         <p:nvPicPr>
-          <p:cNvPr id="19" name=""/>
+          <p:cNvPr id="21" name=""/>
           <p:cNvPicPr>
             <a:picLocks xmlns:a="http://schemas.openxmlformats.org/drawingml/2006/main" noChangeAspect="1"/>
           </p:cNvPicPr>
           <p:nvPr/>
         </p:nvPicPr>
         <p:blipFill>
-          <a:blip xmlns:r="http://schemas.openxmlformats.org/officeDocument/2006/relationships" xmlns:a="http://schemas.openxmlformats.org/drawingml/2006/main" r:embed="R24c7336b9e8c40f0"/>
+          <a:blip xmlns:r="http://schemas.openxmlformats.org/officeDocument/2006/relationships" xmlns:a="http://schemas.openxmlformats.org/drawingml/2006/main" r:embed="R0119adf6f13c4ef9"/>
           <a:srcRect xmlns:a="http://schemas.openxmlformats.org/drawingml/2006/main" l="7605" t="0" r="7605" b="0"/>
           <a:stretch xmlns:a="http://schemas.openxmlformats.org/drawingml/2006/main">
             <a:fillRect l="0" t="0" r="0" b="0"/>
@@ -9864,14 +9864,14 @@
       </p:sp>
       <p:pic>
         <p:nvPicPr>
-          <p:cNvPr id="19" name=""/>
+          <p:cNvPr id="21" name=""/>
           <p:cNvPicPr>
             <a:picLocks xmlns:a="http://schemas.openxmlformats.org/drawingml/2006/main" noChangeAspect="1"/>
           </p:cNvPicPr>
           <p:nvPr/>
         </p:nvPicPr>
         <p:blipFill>
-          <a:blip xmlns:r="http://schemas.openxmlformats.org/officeDocument/2006/relationships" xmlns:a="http://schemas.openxmlformats.org/drawingml/2006/main" r:embed="R80a3bb7bf6b24b83"/>
+          <a:blip xmlns:r="http://schemas.openxmlformats.org/officeDocument/2006/relationships" xmlns:a="http://schemas.openxmlformats.org/drawingml/2006/main" r:embed="Rcf1c4e75a93f466d"/>
           <a:srcRect xmlns:a="http://schemas.openxmlformats.org/drawingml/2006/main" l="1072" t="0" r="1072" b="0"/>
           <a:stretch xmlns:a="http://schemas.openxmlformats.org/drawingml/2006/main">
             <a:fillRect l="0" t="0" r="0" b="0"/>
@@ -10436,151 +10436,6 @@
       </p:sp>
       <p:pic>
         <p:nvPicPr>
-          <p:cNvPr id="17" name=""/>
-          <p:cNvPicPr>
-            <a:picLocks xmlns:a="http://schemas.openxmlformats.org/drawingml/2006/main" noChangeAspect="1"/>
-          </p:cNvPicPr>
-          <p:nvPr/>
-        </p:nvPicPr>
-        <p:blipFill>
-          <a:blip xmlns:r="http://schemas.openxmlformats.org/officeDocument/2006/relationships" xmlns:a="http://schemas.openxmlformats.org/drawingml/2006/main" r:embed="Rc0e787b4ef3441f8"/>
-          <a:stretch xmlns:a="http://schemas.openxmlformats.org/drawingml/2006/main"/>
-        </p:blipFill>
-        <p:spPr>
-          <a:xfrm xmlns:a="http://schemas.openxmlformats.org/drawingml/2006/main">
-            <a:off x="2057400" y="3381375"/>
-            <a:ext cx="2362200" cy="2362200"/>
-          </a:xfrm>
-          <a:prstGeom xmlns:a="http://schemas.openxmlformats.org/drawingml/2006/main" prst="rect">
-            <a:avLst/>
-          </a:prstGeom>
-        </p:spPr>
-      </p:pic>
-      <p:sp>
-        <p:nvSpPr>
-          <p:cNvPr id="6" name="s17-caption-6">
-            <a:extLst xmlns:a="http://schemas.openxmlformats.org/drawingml/2006/main">
-              <a:ext uri="{FF2B5EF4-FFF2-40B4-BE49-F238E27FC236}">
-                <a16:creationId xmlns:a16="http://schemas.microsoft.com/office/drawing/2014/main" id="{A47EDC0F-191F-4722-8D37-3718BC787385}"/>
-              </a:ext>
-            </a:extLst>
-          </p:cNvPr>
-          <p:cNvSpPr>
-            <a:spLocks xmlns:a="http://schemas.openxmlformats.org/drawingml/2006/main" noGrp="1"/>
-          </p:cNvSpPr>
-          <p:nvPr/>
-        </p:nvSpPr>
-        <p:spPr>
-          <a:xfrm xmlns:a="http://schemas.openxmlformats.org/drawingml/2006/main">
-            <a:off x="609600" y="5867400"/>
-            <a:ext cx="5257800" cy="323850"/>
-          </a:xfrm>
-          <a:prstGeom xmlns:a="http://schemas.openxmlformats.org/drawingml/2006/main" prst="rect">
-            <a:avLst/>
-          </a:prstGeom>
-          <a:noFill xmlns:a="http://schemas.openxmlformats.org/drawingml/2006/main"/>
-          <a:ln xmlns:a="http://schemas.openxmlformats.org/drawingml/2006/main" w="0">
-            <a:noFill/>
-          </a:ln>
-        </p:spPr>
-        <p:txBody>
-          <a:bodyPr xmlns:a="http://schemas.openxmlformats.org/drawingml/2006/main" wrap="square" lIns="0" tIns="0" rIns="0" bIns="0" anchor="t">
-            <a:noAutofit/>
-          </a:bodyPr>
-          <a:lstStyle xmlns:a="http://schemas.openxmlformats.org/drawingml/2006/main"/>
-          <a:p xmlns:a="http://schemas.openxmlformats.org/drawingml/2006/main">
-            <a:pPr algn="ctr">
-              <a:lnSpc>
-                <a:spcPct val="116000"/>
-              </a:lnSpc>
-              <a:buNone/>
-              <a:defRPr sz="1575" b="0">
-                <a:solidFill>
-                  <a:srgbClr val="C2CDDB"/>
-                </a:solidFill>
-                <a:latin typeface="Arial"/>
-                <a:ea typeface="Arial"/>
-                <a:cs typeface="Arial"/>
-              </a:defRPr>
-            </a:pPr>
-            <a:r>
-              <a:rPr sz="1575" b="0">
-                <a:solidFill>
-                  <a:srgbClr val="C2CDDB"/>
-                </a:solidFill>
-                <a:latin typeface="Arial"/>
-                <a:ea typeface="Arial"/>
-                <a:cs typeface="Arial"/>
-                <a:hlinkClick xmlns:r="http://schemas.openxmlformats.org/officeDocument/2006/relationships" r:id="R6883c29427ec4558"/>
-              </a:rPr>
-              <a:t>Online slides · current version</a:t>
-            </a:r>
-          </a:p>
-        </p:txBody>
-      </p:sp>
-      <p:sp>
-        <p:nvSpPr>
-          <p:cNvPr id="7" name="s17-subheading-7">
-            <a:extLst xmlns:a="http://schemas.openxmlformats.org/drawingml/2006/main">
-              <a:ext uri="{FF2B5EF4-FFF2-40B4-BE49-F238E27FC236}">
-                <a16:creationId xmlns:a16="http://schemas.microsoft.com/office/drawing/2014/main" id="{7537E5A5-80FE-45B9-868D-8CC3B61490DA}"/>
-              </a:ext>
-            </a:extLst>
-          </p:cNvPr>
-          <p:cNvSpPr>
-            <a:spLocks xmlns:a="http://schemas.openxmlformats.org/drawingml/2006/main" noGrp="1"/>
-          </p:cNvSpPr>
-          <p:nvPr/>
-        </p:nvSpPr>
-        <p:spPr>
-          <a:xfrm xmlns:a="http://schemas.openxmlformats.org/drawingml/2006/main">
-            <a:off x="6248400" y="2886075"/>
-            <a:ext cx="5257800" cy="419100"/>
-          </a:xfrm>
-          <a:prstGeom xmlns:a="http://schemas.openxmlformats.org/drawingml/2006/main" prst="rect">
-            <a:avLst/>
-          </a:prstGeom>
-          <a:noFill xmlns:a="http://schemas.openxmlformats.org/drawingml/2006/main"/>
-          <a:ln xmlns:a="http://schemas.openxmlformats.org/drawingml/2006/main" w="0">
-            <a:noFill/>
-          </a:ln>
-        </p:spPr>
-        <p:txBody>
-          <a:bodyPr xmlns:a="http://schemas.openxmlformats.org/drawingml/2006/main" wrap="square" lIns="0" tIns="0" rIns="0" bIns="0" anchor="t">
-            <a:noAutofit/>
-          </a:bodyPr>
-          <a:lstStyle xmlns:a="http://schemas.openxmlformats.org/drawingml/2006/main"/>
-          <a:p xmlns:a="http://schemas.openxmlformats.org/drawingml/2006/main">
-            <a:pPr algn="ctr">
-              <a:lnSpc>
-                <a:spcPct val="116000"/>
-              </a:lnSpc>
-              <a:buNone/>
-              <a:defRPr sz="2475" b="1">
-                <a:solidFill>
-                  <a:srgbClr val="FFFFFF"/>
-                </a:solidFill>
-                <a:latin typeface="Arial"/>
-                <a:ea typeface="Arial"/>
-                <a:cs typeface="Arial"/>
-              </a:defRPr>
-            </a:pPr>
-            <a:r>
-              <a:rPr sz="2475" b="1">
-                <a:solidFill>
-                  <a:srgbClr val="FFFFFF"/>
-                </a:solidFill>
-                <a:latin typeface="Arial"/>
-                <a:ea typeface="Arial"/>
-                <a:cs typeface="Arial"/>
-              </a:rPr>
-              <a:t>Submission materials</a:t>
-            </a:r>
-          </a:p>
-        </p:txBody>
-      </p:sp>
-      <p:pic>
-        <p:nvPicPr>
           <p:cNvPr id="20" name=""/>
           <p:cNvPicPr>
             <a:picLocks xmlns:a="http://schemas.openxmlformats.org/drawingml/2006/main" noChangeAspect="1"/>
@@ -10588,11 +10443,156 @@
           <p:nvPr/>
         </p:nvPicPr>
         <p:blipFill>
-          <a:blip xmlns:r="http://schemas.openxmlformats.org/officeDocument/2006/relationships" xmlns:a="http://schemas.openxmlformats.org/drawingml/2006/main" r:embed="R6e48471ad3f44ac6"/>
+          <a:blip xmlns:r="http://schemas.openxmlformats.org/officeDocument/2006/relationships" xmlns:a="http://schemas.openxmlformats.org/drawingml/2006/main" r:embed="R9b790c6b8fdc441a"/>
           <a:stretch xmlns:a="http://schemas.openxmlformats.org/drawingml/2006/main"/>
         </p:blipFill>
         <p:spPr>
           <a:xfrm xmlns:a="http://schemas.openxmlformats.org/drawingml/2006/main">
+            <a:off x="2057400" y="3381375"/>
+            <a:ext cx="2362200" cy="2362200"/>
+          </a:xfrm>
+          <a:prstGeom xmlns:a="http://schemas.openxmlformats.org/drawingml/2006/main" prst="rect">
+            <a:avLst/>
+          </a:prstGeom>
+        </p:spPr>
+      </p:pic>
+      <p:sp>
+        <p:nvSpPr>
+          <p:cNvPr id="6" name="s17-caption-6">
+            <a:extLst xmlns:a="http://schemas.openxmlformats.org/drawingml/2006/main">
+              <a:ext uri="{FF2B5EF4-FFF2-40B4-BE49-F238E27FC236}">
+                <a16:creationId xmlns:a16="http://schemas.microsoft.com/office/drawing/2014/main" id="{A47EDC0F-191F-4722-8D37-3718BC787385}"/>
+              </a:ext>
+            </a:extLst>
+          </p:cNvPr>
+          <p:cNvSpPr>
+            <a:spLocks xmlns:a="http://schemas.openxmlformats.org/drawingml/2006/main" noGrp="1"/>
+          </p:cNvSpPr>
+          <p:nvPr/>
+        </p:nvSpPr>
+        <p:spPr>
+          <a:xfrm xmlns:a="http://schemas.openxmlformats.org/drawingml/2006/main">
+            <a:off x="609600" y="5867400"/>
+            <a:ext cx="5257800" cy="323850"/>
+          </a:xfrm>
+          <a:prstGeom xmlns:a="http://schemas.openxmlformats.org/drawingml/2006/main" prst="rect">
+            <a:avLst/>
+          </a:prstGeom>
+          <a:noFill xmlns:a="http://schemas.openxmlformats.org/drawingml/2006/main"/>
+          <a:ln xmlns:a="http://schemas.openxmlformats.org/drawingml/2006/main" w="0">
+            <a:noFill/>
+          </a:ln>
+        </p:spPr>
+        <p:txBody>
+          <a:bodyPr xmlns:a="http://schemas.openxmlformats.org/drawingml/2006/main" wrap="square" lIns="0" tIns="0" rIns="0" bIns="0" anchor="t">
+            <a:noAutofit/>
+          </a:bodyPr>
+          <a:lstStyle xmlns:a="http://schemas.openxmlformats.org/drawingml/2006/main"/>
+          <a:p xmlns:a="http://schemas.openxmlformats.org/drawingml/2006/main">
+            <a:pPr algn="ctr">
+              <a:lnSpc>
+                <a:spcPct val="116000"/>
+              </a:lnSpc>
+              <a:buNone/>
+              <a:defRPr sz="1575" b="0">
+                <a:solidFill>
+                  <a:srgbClr val="C2CDDB"/>
+                </a:solidFill>
+                <a:latin typeface="Arial"/>
+                <a:ea typeface="Arial"/>
+                <a:cs typeface="Arial"/>
+              </a:defRPr>
+            </a:pPr>
+            <a:r>
+              <a:rPr sz="1575" b="0">
+                <a:solidFill>
+                  <a:srgbClr val="C2CDDB"/>
+                </a:solidFill>
+                <a:latin typeface="Arial"/>
+                <a:ea typeface="Arial"/>
+                <a:cs typeface="Arial"/>
+                <a:hlinkClick xmlns:r="http://schemas.openxmlformats.org/officeDocument/2006/relationships" r:id="Rb2488db0e8584bf8"/>
+              </a:rPr>
+              <a:t>Online slides · current version</a:t>
+            </a:r>
+          </a:p>
+        </p:txBody>
+      </p:sp>
+      <p:sp>
+        <p:nvSpPr>
+          <p:cNvPr id="7" name="s17-subheading-7">
+            <a:extLst xmlns:a="http://schemas.openxmlformats.org/drawingml/2006/main">
+              <a:ext uri="{FF2B5EF4-FFF2-40B4-BE49-F238E27FC236}">
+                <a16:creationId xmlns:a16="http://schemas.microsoft.com/office/drawing/2014/main" id="{7537E5A5-80FE-45B9-868D-8CC3B61490DA}"/>
+              </a:ext>
+            </a:extLst>
+          </p:cNvPr>
+          <p:cNvSpPr>
+            <a:spLocks xmlns:a="http://schemas.openxmlformats.org/drawingml/2006/main" noGrp="1"/>
+          </p:cNvSpPr>
+          <p:nvPr/>
+        </p:nvSpPr>
+        <p:spPr>
+          <a:xfrm xmlns:a="http://schemas.openxmlformats.org/drawingml/2006/main">
+            <a:off x="6248400" y="2886075"/>
+            <a:ext cx="5257800" cy="419100"/>
+          </a:xfrm>
+          <a:prstGeom xmlns:a="http://schemas.openxmlformats.org/drawingml/2006/main" prst="rect">
+            <a:avLst/>
+          </a:prstGeom>
+          <a:noFill xmlns:a="http://schemas.openxmlformats.org/drawingml/2006/main"/>
+          <a:ln xmlns:a="http://schemas.openxmlformats.org/drawingml/2006/main" w="0">
+            <a:noFill/>
+          </a:ln>
+        </p:spPr>
+        <p:txBody>
+          <a:bodyPr xmlns:a="http://schemas.openxmlformats.org/drawingml/2006/main" wrap="square" lIns="0" tIns="0" rIns="0" bIns="0" anchor="t">
+            <a:noAutofit/>
+          </a:bodyPr>
+          <a:lstStyle xmlns:a="http://schemas.openxmlformats.org/drawingml/2006/main"/>
+          <a:p xmlns:a="http://schemas.openxmlformats.org/drawingml/2006/main">
+            <a:pPr algn="ctr">
+              <a:lnSpc>
+                <a:spcPct val="116000"/>
+              </a:lnSpc>
+              <a:buNone/>
+              <a:defRPr sz="2475" b="1">
+                <a:solidFill>
+                  <a:srgbClr val="FFFFFF"/>
+                </a:solidFill>
+                <a:latin typeface="Arial"/>
+                <a:ea typeface="Arial"/>
+                <a:cs typeface="Arial"/>
+              </a:defRPr>
+            </a:pPr>
+            <a:r>
+              <a:rPr sz="2475" b="1">
+                <a:solidFill>
+                  <a:srgbClr val="FFFFFF"/>
+                </a:solidFill>
+                <a:latin typeface="Arial"/>
+                <a:ea typeface="Arial"/>
+                <a:cs typeface="Arial"/>
+              </a:rPr>
+              <a:t>Submission materials</a:t>
+            </a:r>
+          </a:p>
+        </p:txBody>
+      </p:sp>
+      <p:pic>
+        <p:nvPicPr>
+          <p:cNvPr id="23" name=""/>
+          <p:cNvPicPr>
+            <a:picLocks xmlns:a="http://schemas.openxmlformats.org/drawingml/2006/main" noChangeAspect="1"/>
+          </p:cNvPicPr>
+          <p:nvPr/>
+        </p:nvPicPr>
+        <p:blipFill>
+          <a:blip xmlns:r="http://schemas.openxmlformats.org/officeDocument/2006/relationships" xmlns:a="http://schemas.openxmlformats.org/drawingml/2006/main" r:embed="R5ec7e357dff04be3"/>
+          <a:stretch xmlns:a="http://schemas.openxmlformats.org/drawingml/2006/main"/>
+        </p:blipFill>
+        <p:spPr>
+          <a:xfrm xmlns:a="http://schemas.openxmlformats.org/drawingml/2006/main">
             <a:off x="7696200" y="3381375"/>
             <a:ext cx="2362200" cy="2362200"/>
           </a:xfrm>
@@ -10656,7 +10656,7 @@
                 <a:latin typeface="Arial"/>
                 <a:ea typeface="Arial"/>
                 <a:cs typeface="Arial"/>
-                <a:hlinkClick xmlns:r="http://schemas.openxmlformats.org/officeDocument/2006/relationships" r:id="Rfda14a1aa63c4785"/>
+                <a:hlinkClick xmlns:r="http://schemas.openxmlformats.org/officeDocument/2006/relationships" r:id="R937d45d14dac4f52"/>
               </a:rPr>
               <a:t>UNESCO submission · studies and evidence</a:t>
             </a:r>
@@ -10779,7 +10779,7 @@
                 <a:latin typeface="Arial"/>
                 <a:ea typeface="Arial"/>
                 <a:cs typeface="Arial"/>
-                <a:hlinkClick xmlns:r="http://schemas.openxmlformats.org/officeDocument/2006/relationships" r:id="Rc6d0d416d2a0493d"/>
+                <a:hlinkClick xmlns:r="http://schemas.openxmlformats.org/officeDocument/2006/relationships" r:id="Rd842d5e9936c403d"/>
               </a:rPr>
               <a:t>tony@cocorobo.cc</a:t>
             </a:r>
@@ -11488,14 +11488,14 @@
       </p:sp>
       <p:pic>
         <p:nvPicPr>
-          <p:cNvPr id="27" name=""/>
+          <p:cNvPr id="29" name=""/>
           <p:cNvPicPr>
             <a:picLocks xmlns:a="http://schemas.openxmlformats.org/drawingml/2006/main" noChangeAspect="1"/>
           </p:cNvPicPr>
           <p:nvPr/>
         </p:nvPicPr>
         <p:blipFill>
-          <a:blip xmlns:r="http://schemas.openxmlformats.org/officeDocument/2006/relationships" xmlns:a="http://schemas.openxmlformats.org/drawingml/2006/main" r:embed="R510bc96076c0425d"/>
+          <a:blip xmlns:r="http://schemas.openxmlformats.org/officeDocument/2006/relationships" xmlns:a="http://schemas.openxmlformats.org/drawingml/2006/main" r:embed="R42cfc9c4f4de4043"/>
           <a:stretch xmlns:a="http://schemas.openxmlformats.org/drawingml/2006/main"/>
         </p:blipFill>
         <p:spPr>
@@ -12931,7 +12931,7 @@
                 <a:latin typeface="Arial"/>
                 <a:ea typeface="Arial"/>
                 <a:cs typeface="Arial"/>
-                <a:hlinkClick xmlns:r="http://schemas.openxmlformats.org/officeDocument/2006/relationships" r:id="R57c845d2da4b478a"/>
+                <a:hlinkClick xmlns:r="http://schemas.openxmlformats.org/officeDocument/2006/relationships" r:id="Rfa1bfa4d52c94faa"/>
               </a:rPr>
               <a:t>Guangdong Department</a:t>
             </a:r>
@@ -12959,7 +12959,7 @@
                 <a:latin typeface="Arial"/>
                 <a:ea typeface="Arial"/>
                 <a:cs typeface="Arial"/>
-                <a:hlinkClick xmlns:r="http://schemas.openxmlformats.org/officeDocument/2006/relationships" r:id="R27cfdaa59dcd4082"/>
+                <a:hlinkClick xmlns:r="http://schemas.openxmlformats.org/officeDocument/2006/relationships" r:id="Rf2225d262e8e4e0f"/>
               </a:rPr>
               <a:t>of Education · 9 April 2025</a:t>
             </a:r>
@@ -12987,7 +12987,7 @@
                 <a:latin typeface="Arial"/>
                 <a:ea typeface="Arial"/>
                 <a:cs typeface="Arial"/>
-                <a:hlinkClick xmlns:r="http://schemas.openxmlformats.org/officeDocument/2006/relationships" r:id="Rc6c87849a519487d"/>
+                <a:hlinkClick xmlns:r="http://schemas.openxmlformats.org/officeDocument/2006/relationships" r:id="Rbb1d84ea27de48cb"/>
               </a:rPr>
               <a:t>Trial documents</a:t>
             </a:r>
@@ -13970,14 +13970,14 @@
       </p:sp>
       <p:pic>
         <p:nvPicPr>
-          <p:cNvPr id="20" name=""/>
+          <p:cNvPr id="23" name=""/>
           <p:cNvPicPr>
             <a:picLocks xmlns:a="http://schemas.openxmlformats.org/drawingml/2006/main" noChangeAspect="1"/>
           </p:cNvPicPr>
           <p:nvPr/>
         </p:nvPicPr>
         <p:blipFill>
-          <a:blip xmlns:r="http://schemas.openxmlformats.org/officeDocument/2006/relationships" xmlns:a="http://schemas.openxmlformats.org/drawingml/2006/main" r:embed="R94bb3e5e31a3416e"/>
+          <a:blip xmlns:r="http://schemas.openxmlformats.org/officeDocument/2006/relationships" xmlns:a="http://schemas.openxmlformats.org/drawingml/2006/main" r:embed="R238893813fbd4324"/>
           <a:stretch xmlns:a="http://schemas.openxmlformats.org/drawingml/2006/main"/>
         </p:blipFill>
         <p:spPr>
@@ -13992,14 +13992,14 @@
       </p:pic>
       <p:pic>
         <p:nvPicPr>
-          <p:cNvPr id="21" name=""/>
+          <p:cNvPr id="24" name=""/>
           <p:cNvPicPr>
             <a:picLocks xmlns:a="http://schemas.openxmlformats.org/drawingml/2006/main" noChangeAspect="1"/>
           </p:cNvPicPr>
           <p:nvPr/>
         </p:nvPicPr>
         <p:blipFill>
-          <a:blip xmlns:r="http://schemas.openxmlformats.org/officeDocument/2006/relationships" xmlns:a="http://schemas.openxmlformats.org/drawingml/2006/main" r:embed="R9f62a231292340b7"/>
+          <a:blip xmlns:r="http://schemas.openxmlformats.org/officeDocument/2006/relationships" xmlns:a="http://schemas.openxmlformats.org/drawingml/2006/main" r:embed="R11b12fa420bc4362"/>
           <a:srcRect xmlns:a="http://schemas.openxmlformats.org/drawingml/2006/main" l="0" t="24809" r="0" b="24809"/>
           <a:stretch xmlns:a="http://schemas.openxmlformats.org/drawingml/2006/main">
             <a:fillRect l="0" t="0" r="0" b="0"/>
@@ -14686,15 +14686,15 @@
       </p:sp>
       <p:pic>
         <p:nvPicPr>
-          <p:cNvPr id="20" name=""/>
+          <p:cNvPr id="22" name=""/>
           <p:cNvPicPr>
             <a:picLocks xmlns:a="http://schemas.openxmlformats.org/drawingml/2006/main" noChangeAspect="1"/>
           </p:cNvPicPr>
           <p:nvPr/>
         </p:nvPicPr>
         <p:blipFill>
-          <a:blip xmlns:r="http://schemas.openxmlformats.org/officeDocument/2006/relationships" xmlns:a="http://schemas.openxmlformats.org/drawingml/2006/main" r:embed="R1517f7e98b06462f"/>
-          <a:srcRect xmlns:a="http://schemas.openxmlformats.org/drawingml/2006/main" l="9911" t="0" r="9911" b="0"/>
+          <a:blip xmlns:r="http://schemas.openxmlformats.org/officeDocument/2006/relationships" xmlns:a="http://schemas.openxmlformats.org/drawingml/2006/main" r:embed="Rf77b7972da814382"/>
+          <a:srcRect xmlns:a="http://schemas.openxmlformats.org/drawingml/2006/main" l="0" t="12735" r="0" b="12735"/>
           <a:stretch xmlns:a="http://schemas.openxmlformats.org/drawingml/2006/main">
             <a:fillRect l="0" t="0" r="0" b="0"/>
           </a:stretch>
@@ -14765,7 +14765,7 @@
                 <a:ea typeface="Arial"/>
                 <a:cs typeface="Arial"/>
               </a:rPr>
-              <a:t>Teachers discuss their agent designs · Pingshan</a:t>
+              <a:t>AI pioneer teacher programme · Pingshan</a:t>
             </a:r>
           </a:p>
         </p:txBody>
@@ -15441,14 +15441,14 @@
       </p:sp>
       <p:pic>
         <p:nvPicPr>
-          <p:cNvPr id="19" name=""/>
+          <p:cNvPr id="21" name=""/>
           <p:cNvPicPr>
             <a:picLocks xmlns:a="http://schemas.openxmlformats.org/drawingml/2006/main" noChangeAspect="1"/>
           </p:cNvPicPr>
           <p:nvPr/>
         </p:nvPicPr>
         <p:blipFill>
-          <a:blip xmlns:r="http://schemas.openxmlformats.org/officeDocument/2006/relationships" xmlns:a="http://schemas.openxmlformats.org/drawingml/2006/main" r:embed="R5c6212cc3ac643e8"/>
+          <a:blip xmlns:r="http://schemas.openxmlformats.org/officeDocument/2006/relationships" xmlns:a="http://schemas.openxmlformats.org/drawingml/2006/main" r:embed="R87e6ec2948a643f4"/>
           <a:srcRect xmlns:a="http://schemas.openxmlformats.org/drawingml/2006/main" l="3932" t="0" r="3932" b="0"/>
           <a:stretch xmlns:a="http://schemas.openxmlformats.org/drawingml/2006/main">
             <a:fillRect l="0" t="0" r="0" b="0"/>
@@ -16379,14 +16379,14 @@
       </p:sp>
       <p:pic>
         <p:nvPicPr>
-          <p:cNvPr id="28" name=""/>
+          <p:cNvPr id="30" name=""/>
           <p:cNvPicPr>
             <a:picLocks xmlns:a="http://schemas.openxmlformats.org/drawingml/2006/main" noChangeAspect="1"/>
           </p:cNvPicPr>
           <p:nvPr/>
         </p:nvPicPr>
         <p:blipFill>
-          <a:blip xmlns:r="http://schemas.openxmlformats.org/officeDocument/2006/relationships" xmlns:a="http://schemas.openxmlformats.org/drawingml/2006/main" r:embed="R69049649d56c4e99"/>
+          <a:blip xmlns:r="http://schemas.openxmlformats.org/officeDocument/2006/relationships" xmlns:a="http://schemas.openxmlformats.org/drawingml/2006/main" r:embed="R75003e61cd8e49d2"/>
           <a:stretch xmlns:a="http://schemas.openxmlformats.org/drawingml/2006/main"/>
         </p:blipFill>
         <p:spPr>
@@ -16948,14 +16948,14 @@
       </p:sp>
       <p:pic>
         <p:nvPicPr>
-          <p:cNvPr id="19" name=""/>
+          <p:cNvPr id="21" name=""/>
           <p:cNvPicPr>
             <a:picLocks xmlns:a="http://schemas.openxmlformats.org/drawingml/2006/main" noChangeAspect="1"/>
           </p:cNvPicPr>
           <p:nvPr/>
         </p:nvPicPr>
         <p:blipFill>
-          <a:blip xmlns:r="http://schemas.openxmlformats.org/officeDocument/2006/relationships" xmlns:a="http://schemas.openxmlformats.org/drawingml/2006/main" r:embed="R30aead142a354874"/>
+          <a:blip xmlns:r="http://schemas.openxmlformats.org/officeDocument/2006/relationships" xmlns:a="http://schemas.openxmlformats.org/drawingml/2006/main" r:embed="Rfda521be8bd14bdd"/>
           <a:srcRect xmlns:a="http://schemas.openxmlformats.org/drawingml/2006/main" l="0" t="6756" r="0" b="6756"/>
           <a:stretch xmlns:a="http://schemas.openxmlformats.org/drawingml/2006/main">
             <a:fillRect l="0" t="0" r="0" b="0"/>

</xml_diff>

<commit_message>
Update UNESCO deck with authentic workshop, Guangdong policy and APEC 2026 imagery
</commit_message>
<xml_diff>
--- a/teacher-agent-creators-10min/downloads/UNESCO_Teacher_AI_Agents_EN.pptx
+++ b/teacher-agent-creators-10min/downloads/UNESCO_Teacher_AI_Agents_EN.pptx
@@ -2,29 +2,29 @@
 <file path=ppt/presentation.xml><?xml version="1.0" encoding="utf-8"?>
 <p:presentation xmlns:p="http://schemas.openxmlformats.org/presentationml/2006/main">
   <p:sldMasterIdLst>
-    <p:sldMasterId xmlns:r="http://schemas.openxmlformats.org/officeDocument/2006/relationships" id="2147483648" r:id="Rcc7aacccec1f452a"/>
+    <p:sldMasterId xmlns:r="http://schemas.openxmlformats.org/officeDocument/2006/relationships" id="2147483648" r:id="R5e5a5fb2821244a0"/>
   </p:sldMasterIdLst>
   <p:notesMasterIdLst>
-    <p:notesMasterId xmlns:r="http://schemas.openxmlformats.org/officeDocument/2006/relationships" r:id="R663d9e55a96d4c54"/>
+    <p:notesMasterId xmlns:r="http://schemas.openxmlformats.org/officeDocument/2006/relationships" r:id="Reab8ed9f4d874136"/>
   </p:notesMasterIdLst>
   <p:sldIdLst>
-    <p:sldId xmlns:r="http://schemas.openxmlformats.org/officeDocument/2006/relationships" id="256" r:id="R9992a173f346466a"/>
-    <p:sldId xmlns:r="http://schemas.openxmlformats.org/officeDocument/2006/relationships" id="257" r:id="R7c680c8bbac94bd5"/>
-    <p:sldId xmlns:r="http://schemas.openxmlformats.org/officeDocument/2006/relationships" id="258" r:id="R29f2c76382e34b44"/>
-    <p:sldId xmlns:r="http://schemas.openxmlformats.org/officeDocument/2006/relationships" id="259" r:id="Ra43145481b0e4805"/>
-    <p:sldId xmlns:r="http://schemas.openxmlformats.org/officeDocument/2006/relationships" id="260" r:id="R643d6878363042f2"/>
-    <p:sldId xmlns:r="http://schemas.openxmlformats.org/officeDocument/2006/relationships" id="261" r:id="R2e50548429e14704"/>
-    <p:sldId xmlns:r="http://schemas.openxmlformats.org/officeDocument/2006/relationships" id="262" r:id="R4df963f665d849db"/>
-    <p:sldId xmlns:r="http://schemas.openxmlformats.org/officeDocument/2006/relationships" id="263" r:id="R9012be56ce244b4e"/>
-    <p:sldId xmlns:r="http://schemas.openxmlformats.org/officeDocument/2006/relationships" id="264" r:id="R34223ca6f8184cfe"/>
-    <p:sldId xmlns:r="http://schemas.openxmlformats.org/officeDocument/2006/relationships" id="265" r:id="Rfe7fb924e79d451d"/>
-    <p:sldId xmlns:r="http://schemas.openxmlformats.org/officeDocument/2006/relationships" id="266" r:id="Ra7b94b7831f440a6"/>
-    <p:sldId xmlns:r="http://schemas.openxmlformats.org/officeDocument/2006/relationships" id="267" r:id="Rddb70726294d4486"/>
-    <p:sldId xmlns:r="http://schemas.openxmlformats.org/officeDocument/2006/relationships" id="268" r:id="Rfa0a2f5184de4d34"/>
-    <p:sldId xmlns:r="http://schemas.openxmlformats.org/officeDocument/2006/relationships" id="269" r:id="Red2e5b60351f4731"/>
-    <p:sldId xmlns:r="http://schemas.openxmlformats.org/officeDocument/2006/relationships" id="270" r:id="R6e3e464e530a4e07"/>
-    <p:sldId xmlns:r="http://schemas.openxmlformats.org/officeDocument/2006/relationships" id="271" r:id="Rb45177467fc54b9e"/>
-    <p:sldId xmlns:r="http://schemas.openxmlformats.org/officeDocument/2006/relationships" id="272" r:id="Rf797a94e99cd41bf"/>
+    <p:sldId xmlns:r="http://schemas.openxmlformats.org/officeDocument/2006/relationships" id="256" r:id="Rd693c781e30147ba"/>
+    <p:sldId xmlns:r="http://schemas.openxmlformats.org/officeDocument/2006/relationships" id="257" r:id="Rff75ddf2f5a445bd"/>
+    <p:sldId xmlns:r="http://schemas.openxmlformats.org/officeDocument/2006/relationships" id="258" r:id="Rc1eb07cddbe74244"/>
+    <p:sldId xmlns:r="http://schemas.openxmlformats.org/officeDocument/2006/relationships" id="259" r:id="R59d4f013a5da451e"/>
+    <p:sldId xmlns:r="http://schemas.openxmlformats.org/officeDocument/2006/relationships" id="260" r:id="R438ed5b165194816"/>
+    <p:sldId xmlns:r="http://schemas.openxmlformats.org/officeDocument/2006/relationships" id="261" r:id="Rd0dd79d269e04eb7"/>
+    <p:sldId xmlns:r="http://schemas.openxmlformats.org/officeDocument/2006/relationships" id="262" r:id="R30a17d21ae8b4042"/>
+    <p:sldId xmlns:r="http://schemas.openxmlformats.org/officeDocument/2006/relationships" id="263" r:id="R39d849937d984435"/>
+    <p:sldId xmlns:r="http://schemas.openxmlformats.org/officeDocument/2006/relationships" id="264" r:id="Rc7e71c8fa6da440a"/>
+    <p:sldId xmlns:r="http://schemas.openxmlformats.org/officeDocument/2006/relationships" id="265" r:id="R70b13bd2d1e4468a"/>
+    <p:sldId xmlns:r="http://schemas.openxmlformats.org/officeDocument/2006/relationships" id="266" r:id="Rdec9ef6803d24a68"/>
+    <p:sldId xmlns:r="http://schemas.openxmlformats.org/officeDocument/2006/relationships" id="267" r:id="R97f9faa8830e4763"/>
+    <p:sldId xmlns:r="http://schemas.openxmlformats.org/officeDocument/2006/relationships" id="268" r:id="R3fdd358eb25b4c53"/>
+    <p:sldId xmlns:r="http://schemas.openxmlformats.org/officeDocument/2006/relationships" id="269" r:id="R3812738641c648c0"/>
+    <p:sldId xmlns:r="http://schemas.openxmlformats.org/officeDocument/2006/relationships" id="270" r:id="R490db68999b14d82"/>
+    <p:sldId xmlns:r="http://schemas.openxmlformats.org/officeDocument/2006/relationships" id="271" r:id="Rec05f91c08f043e5"/>
+    <p:sldId xmlns:r="http://schemas.openxmlformats.org/officeDocument/2006/relationships" id="272" r:id="Rd945e029b4454e6e"/>
   </p:sldIdLst>
   <p:sldSz cx="12192000" cy="6858000"/>
   <p:notesSz cx="6858000" cy="9144000"/>
@@ -501,6 +501,11 @@
               <a:t>Evidence scope follows the original deck. Design implications are not additional experimental findings.</a:t>
             </a:r>
           </a:p>
+          <a:p xmlns:a="http://schemas.openxmlformats.org/drawingml/2006/main">
+            <a:r>
+              <a:t>Cover photo: user-supplied IMG_3940.gif, a teacher workshop discussion in Pingshan. A still frame is used; no people or scene elements were generated.</a:t>
+            </a:r>
+          </a:p>
         </p:txBody>
       </p:sp>
       <p:sp>
@@ -1318,7 +1323,7 @@
           </a:p>
           <a:p xmlns:a="http://schemas.openxmlformats.org/drawingml/2006/main">
             <a:r>
-              <a:t>Photo: Shenzhen Education Bureau source deck, slide 2 (city-s2-img3.jpeg), teacher application-contest community. This photo is not an APEC venue or event.</a:t>
+              <a:t>Official APEC China 2026 emblem: Xinhua, 12 December 2025, https://www.xinhuanet.com/20251212/1d1dad261ca34e259c55c672e8497cfe/c.html . Image: https://www.xinhuanet.com/20251212/1d1dad261ca34e259c55c672e8497cfe/202512121d1dad261ca34e259c55c672e8497cfe_912aa6ef9651489b8acd6054075d0fbb.jpg . Identity cross-checked against the official host-year website https://www.apec2026.cn/ and Shenzhen government announcement https://www.sz.gov.cn/en_szgov/news/latest/content/post_12546149.html (checked 8 September 2026). Emblem reproduced without alteration.</a:t>
             </a:r>
           </a:p>
         </p:txBody>
@@ -1753,7 +1758,7 @@
           </a:p>
           <a:p xmlns:a="http://schemas.openxmlformats.org/drawingml/2006/main">
             <a:r>
-              <a:t>Primary drafting-team account: South China Normal University, 1 May 2025, https://news.scnu.edu.cn/71155/469 . English labels are concise translations. The official PDF cover downloads were unavailable; this slide uses native English text and links to the official notice, without recreated or invented document images. Policy is context, not a claim that Guangdong formally joined this particular research partnership or caused the earlier Shenzhen platform. The takeaway is our synthesis.</a:t>
+              <a:t>Primary drafting-team account: South China Normal University, 1 May 2025, https://news.scnu.edu.cn/71155/469 . English labels are concise translations. Notice image: user-supplied 42030.png, an authentic screenshot of the Guangdong Department of Education website. The crop shows the department header, complete notice title and website publication date (10 April 2025). The signed document was issued on 9 April 2025. The original full screenshot is preserved in the online assets. Policy is context, not a claim that Guangdong formally joined this particular research partnership or caused the earlier Shenzhen platform. The takeaway is our synthesis.</a:t>
             </a:r>
           </a:p>
         </p:txBody>
@@ -2411,7 +2416,7 @@
   </p:cSld>
   <p:clrMap bg1="lt1" tx1="dk1" bg2="lt2" tx2="dk2" accent1="accent1" accent2="accent2" accent3="accent3" accent4="accent4" accent5="accent5" accent6="accent6" hlink="hlink" folHlink="folHlink"/>
   <p:sldLayoutIdLst>
-    <p:sldLayoutId xmlns:r="http://schemas.openxmlformats.org/officeDocument/2006/relationships" id="2147483649" r:id="Rb785264ccd3f4cd0"/>
+    <p:sldLayoutId xmlns:r="http://schemas.openxmlformats.org/officeDocument/2006/relationships" id="2147483649" r:id="Rf24c614b522d4059"/>
   </p:sldLayoutIdLst>
   <p:txStyles>
     <p:titleStyle>
@@ -2966,16 +2971,13 @@
           <p:nvPr/>
         </p:nvPicPr>
         <p:blipFill>
-          <a:blip xmlns:r="http://schemas.openxmlformats.org/officeDocument/2006/relationships" xmlns:a="http://schemas.openxmlformats.org/drawingml/2006/main" r:embed="R3bc28af368de4975"/>
-          <a:srcRect xmlns:a="http://schemas.openxmlformats.org/drawingml/2006/main" l="4583" t="0" r="4583" b="0"/>
-          <a:stretch xmlns:a="http://schemas.openxmlformats.org/drawingml/2006/main">
-            <a:fillRect l="0" t="0" r="0" b="0"/>
-          </a:stretch>
+          <a:blip xmlns:r="http://schemas.openxmlformats.org/officeDocument/2006/relationships" xmlns:a="http://schemas.openxmlformats.org/drawingml/2006/main" r:embed="R602e19df60b14856"/>
+          <a:stretch xmlns:a="http://schemas.openxmlformats.org/drawingml/2006/main"/>
         </p:blipFill>
         <p:spPr>
           <a:xfrm xmlns:a="http://schemas.openxmlformats.org/drawingml/2006/main">
-            <a:off x="6667500" y="1743075"/>
-            <a:ext cx="5524500" cy="4562475"/>
+            <a:off x="6667500" y="2047875"/>
+            <a:ext cx="5524500" cy="3680698"/>
           </a:xfrm>
           <a:prstGeom xmlns:a="http://schemas.openxmlformats.org/drawingml/2006/main" prst="rect">
             <a:avLst/>
@@ -2991,7 +2993,7 @@
           <p:nvPr/>
         </p:nvPicPr>
         <p:blipFill>
-          <a:blip xmlns:r="http://schemas.openxmlformats.org/officeDocument/2006/relationships" xmlns:a="http://schemas.openxmlformats.org/drawingml/2006/main" r:embed="Rd2f55b1bf2014b60"/>
+          <a:blip xmlns:r="http://schemas.openxmlformats.org/officeDocument/2006/relationships" xmlns:a="http://schemas.openxmlformats.org/drawingml/2006/main" r:embed="Rb7d9f53e33f54166"/>
           <a:srcRect xmlns:a="http://schemas.openxmlformats.org/drawingml/2006/main" l="0" t="0" r="0" b="0"/>
           <a:stretch xmlns:a="http://schemas.openxmlformats.org/drawingml/2006/main"/>
         </p:blipFill>
@@ -5343,7 +5345,7 @@
           <p:nvPr/>
         </p:nvPicPr>
         <p:blipFill>
-          <a:blip xmlns:r="http://schemas.openxmlformats.org/officeDocument/2006/relationships" xmlns:a="http://schemas.openxmlformats.org/drawingml/2006/main" r:embed="R01243f2e8ca44cae"/>
+          <a:blip xmlns:r="http://schemas.openxmlformats.org/officeDocument/2006/relationships" xmlns:a="http://schemas.openxmlformats.org/drawingml/2006/main" r:embed="R830f6c19291d44b3"/>
           <a:srcRect xmlns:a="http://schemas.openxmlformats.org/drawingml/2006/main" l="0" t="0" r="0" b="0"/>
           <a:stretch xmlns:a="http://schemas.openxmlformats.org/drawingml/2006/main"/>
         </p:blipFill>
@@ -6062,7 +6064,7 @@
           <p:nvPr/>
         </p:nvPicPr>
         <p:blipFill>
-          <a:blip xmlns:r="http://schemas.openxmlformats.org/officeDocument/2006/relationships" xmlns:a="http://schemas.openxmlformats.org/drawingml/2006/main" r:embed="Rd50351554b824a42"/>
+          <a:blip xmlns:r="http://schemas.openxmlformats.org/officeDocument/2006/relationships" xmlns:a="http://schemas.openxmlformats.org/drawingml/2006/main" r:embed="R960656aa26ad4989"/>
           <a:srcRect xmlns:a="http://schemas.openxmlformats.org/drawingml/2006/main" l="7910" t="0" r="7910" b="0"/>
           <a:stretch xmlns:a="http://schemas.openxmlformats.org/drawingml/2006/main">
             <a:fillRect l="0" t="0" r="0" b="0"/>
@@ -10089,16 +10091,13 @@
           <p:nvPr/>
         </p:nvPicPr>
         <p:blipFill>
-          <a:blip xmlns:r="http://schemas.openxmlformats.org/officeDocument/2006/relationships" xmlns:a="http://schemas.openxmlformats.org/drawingml/2006/main" r:embed="Rc1973e2055244ad6"/>
-          <a:srcRect xmlns:a="http://schemas.openxmlformats.org/drawingml/2006/main" l="4441" t="0" r="4441" b="0"/>
-          <a:stretch xmlns:a="http://schemas.openxmlformats.org/drawingml/2006/main">
-            <a:fillRect l="0" t="0" r="0" b="0"/>
-          </a:stretch>
+          <a:blip xmlns:r="http://schemas.openxmlformats.org/officeDocument/2006/relationships" xmlns:a="http://schemas.openxmlformats.org/drawingml/2006/main" r:embed="R9de25845d22a454f"/>
+          <a:stretch xmlns:a="http://schemas.openxmlformats.org/drawingml/2006/main"/>
         </p:blipFill>
         <p:spPr>
           <a:xfrm xmlns:a="http://schemas.openxmlformats.org/drawingml/2006/main">
-            <a:off x="6400800" y="1695450"/>
-            <a:ext cx="5257800" cy="3848100"/>
+            <a:off x="6400800" y="1760786"/>
+            <a:ext cx="5257800" cy="3717429"/>
           </a:xfrm>
           <a:prstGeom xmlns:a="http://schemas.openxmlformats.org/drawingml/2006/main" prst="rect">
             <a:avLst/>
@@ -10161,7 +10160,7 @@
                 <a:ea typeface="Arial"/>
                 <a:cs typeface="Arial"/>
               </a:rPr>
-              <a:t>Shenzhen teacher community · city application contest</a:t>
+              <a:t>APEC China 2026 · official emblem</a:t>
             </a:r>
           </a:p>
         </p:txBody>
@@ -10715,7 +10714,7 @@
           <p:nvPr/>
         </p:nvPicPr>
         <p:blipFill>
-          <a:blip xmlns:r="http://schemas.openxmlformats.org/officeDocument/2006/relationships" xmlns:a="http://schemas.openxmlformats.org/drawingml/2006/main" r:embed="Rf9dbf668ec964f11"/>
+          <a:blip xmlns:r="http://schemas.openxmlformats.org/officeDocument/2006/relationships" xmlns:a="http://schemas.openxmlformats.org/drawingml/2006/main" r:embed="Rc53853acec824596"/>
           <a:srcRect xmlns:a="http://schemas.openxmlformats.org/drawingml/2006/main" l="0" t="0" r="0" b="0"/>
           <a:stretch xmlns:a="http://schemas.openxmlformats.org/drawingml/2006/main"/>
         </p:blipFill>
@@ -10784,7 +10783,7 @@
                 <a:latin typeface="Arial"/>
                 <a:ea typeface="Arial"/>
                 <a:cs typeface="Arial"/>
-                <a:hlinkClick xmlns:r="http://schemas.openxmlformats.org/officeDocument/2006/relationships" r:id="R7591179020d74ad8"/>
+                <a:hlinkClick xmlns:r="http://schemas.openxmlformats.org/officeDocument/2006/relationships" r:id="Rb76e0860554e4b56"/>
               </a:rPr>
               <a:t>Online slides ·</a:t>
             </a:r>
@@ -10812,7 +10811,7 @@
                 <a:latin typeface="Arial"/>
                 <a:ea typeface="Arial"/>
                 <a:cs typeface="Arial"/>
-                <a:hlinkClick xmlns:r="http://schemas.openxmlformats.org/officeDocument/2006/relationships" r:id="R78e7e12c04624e73"/>
+                <a:hlinkClick xmlns:r="http://schemas.openxmlformats.org/officeDocument/2006/relationships" r:id="Rce5c828bce25475c"/>
               </a:rPr>
               <a:t>current version</a:t>
             </a:r>
@@ -10916,7 +10915,7 @@
           <p:nvPr/>
         </p:nvPicPr>
         <p:blipFill>
-          <a:blip xmlns:r="http://schemas.openxmlformats.org/officeDocument/2006/relationships" xmlns:a="http://schemas.openxmlformats.org/drawingml/2006/main" r:embed="Ra97a38077b714142"/>
+          <a:blip xmlns:r="http://schemas.openxmlformats.org/officeDocument/2006/relationships" xmlns:a="http://schemas.openxmlformats.org/drawingml/2006/main" r:embed="Rf8b8311e25794fa3"/>
           <a:srcRect xmlns:a="http://schemas.openxmlformats.org/drawingml/2006/main" l="0" t="0" r="0" b="0"/>
           <a:stretch xmlns:a="http://schemas.openxmlformats.org/drawingml/2006/main"/>
         </p:blipFill>
@@ -10985,7 +10984,7 @@
                 <a:latin typeface="Arial"/>
                 <a:ea typeface="Arial"/>
                 <a:cs typeface="Arial"/>
-                <a:hlinkClick xmlns:r="http://schemas.openxmlformats.org/officeDocument/2006/relationships" r:id="R75bfc0607bfd4ee5"/>
+                <a:hlinkClick xmlns:r="http://schemas.openxmlformats.org/officeDocument/2006/relationships" r:id="Raa4300958e3747c6"/>
               </a:rPr>
               <a:t>UNESCO submission ·</a:t>
             </a:r>
@@ -11013,7 +11012,7 @@
                 <a:latin typeface="Arial"/>
                 <a:ea typeface="Arial"/>
                 <a:cs typeface="Arial"/>
-                <a:hlinkClick xmlns:r="http://schemas.openxmlformats.org/officeDocument/2006/relationships" r:id="R442a53b5149c48a9"/>
+                <a:hlinkClick xmlns:r="http://schemas.openxmlformats.org/officeDocument/2006/relationships" r:id="Rf15e241885a0414f"/>
               </a:rPr>
               <a:t>studies and evidence</a:t>
             </a:r>
@@ -11163,7 +11162,7 @@
                 <a:latin typeface="Arial"/>
                 <a:ea typeface="Arial"/>
                 <a:cs typeface="Arial"/>
-                <a:hlinkClick xmlns:r="http://schemas.openxmlformats.org/officeDocument/2006/relationships" r:id="Rffc5daf88c4046ba"/>
+                <a:hlinkClick xmlns:r="http://schemas.openxmlformats.org/officeDocument/2006/relationships" r:id="R8c9bcff218664216"/>
               </a:rPr>
               <a:t>tony@cocorobo.cc</a:t>
             </a:r>
@@ -11879,7 +11878,7 @@
           <p:nvPr/>
         </p:nvPicPr>
         <p:blipFill>
-          <a:blip xmlns:r="http://schemas.openxmlformats.org/officeDocument/2006/relationships" xmlns:a="http://schemas.openxmlformats.org/drawingml/2006/main" r:embed="R3969822723f84ffe"/>
+          <a:blip xmlns:r="http://schemas.openxmlformats.org/officeDocument/2006/relationships" xmlns:a="http://schemas.openxmlformats.org/drawingml/2006/main" r:embed="R2313b2b57815420e"/>
           <a:srcRect xmlns:a="http://schemas.openxmlformats.org/drawingml/2006/main" l="0" t="2370" r="0" b="2370"/>
           <a:stretch xmlns:a="http://schemas.openxmlformats.org/drawingml/2006/main"/>
         </p:blipFill>
@@ -13243,29 +13242,29 @@
         </p:nvSpPr>
         <p:spPr>
           <a:xfrm xmlns:a="http://schemas.openxmlformats.org/drawingml/2006/main">
-            <a:off x="533400" y="2876550"/>
-            <a:ext cx="3486150" cy="1447800"/>
-          </a:xfrm>
-          <a:prstGeom xmlns:a="http://schemas.openxmlformats.org/drawingml/2006/main" prst="rect">
-            <a:avLst/>
-          </a:prstGeom>
-          <a:noFill xmlns:a="http://schemas.openxmlformats.org/drawingml/2006/main"/>
-          <a:ln xmlns:a="http://schemas.openxmlformats.org/drawingml/2006/main" w="0">
-            <a:noFill/>
-          </a:ln>
-        </p:spPr>
-        <p:txBody>
-          <a:bodyPr xmlns:a="http://schemas.openxmlformats.org/drawingml/2006/main" wrap="square" lIns="0" tIns="0" rIns="0" bIns="0" anchor="t">
-            <a:noAutofit/>
-          </a:bodyPr>
-          <a:lstStyle xmlns:a="http://schemas.openxmlformats.org/drawingml/2006/main"/>
-          <a:p xmlns:a="http://schemas.openxmlformats.org/drawingml/2006/main">
-            <a:pPr algn="l">
-              <a:lnSpc>
-                <a:spcPct val="120000"/>
-              </a:lnSpc>
-              <a:buNone/>
-              <a:defRPr sz="9000" b="1">
+            <a:off x="533400" y="2524125"/>
+            <a:ext cx="3810000" cy="523875"/>
+          </a:xfrm>
+          <a:prstGeom xmlns:a="http://schemas.openxmlformats.org/drawingml/2006/main" prst="rect">
+            <a:avLst/>
+          </a:prstGeom>
+          <a:noFill xmlns:a="http://schemas.openxmlformats.org/drawingml/2006/main"/>
+          <a:ln xmlns:a="http://schemas.openxmlformats.org/drawingml/2006/main" w="0">
+            <a:noFill/>
+          </a:ln>
+        </p:spPr>
+        <p:txBody>
+          <a:bodyPr xmlns:a="http://schemas.openxmlformats.org/drawingml/2006/main" wrap="square" lIns="0" tIns="0" rIns="0" bIns="0" anchor="t">
+            <a:noAutofit/>
+          </a:bodyPr>
+          <a:lstStyle xmlns:a="http://schemas.openxmlformats.org/drawingml/2006/main"/>
+          <a:p xmlns:a="http://schemas.openxmlformats.org/drawingml/2006/main">
+            <a:pPr algn="l">
+              <a:lnSpc>
+                <a:spcPct val="120000"/>
+              </a:lnSpc>
+              <a:buNone/>
+              <a:defRPr sz="3300" b="1">
                 <a:solidFill>
                   <a:srgbClr val="175DA8"/>
                 </a:solidFill>
@@ -13275,7 +13274,7 @@
               </a:defRPr>
             </a:pPr>
             <a:r>
-              <a:rPr sz="9000" b="1">
+              <a:rPr sz="3300" b="1">
                 <a:solidFill>
                   <a:srgbClr val="175DA8"/>
                 </a:solidFill>
@@ -13304,29 +13303,29 @@
         </p:nvSpPr>
         <p:spPr>
           <a:xfrm xmlns:a="http://schemas.openxmlformats.org/drawingml/2006/main">
-            <a:off x="590550" y="4610100"/>
-            <a:ext cx="3095625" cy="990600"/>
-          </a:xfrm>
-          <a:prstGeom xmlns:a="http://schemas.openxmlformats.org/drawingml/2006/main" prst="rect">
-            <a:avLst/>
-          </a:prstGeom>
-          <a:noFill xmlns:a="http://schemas.openxmlformats.org/drawingml/2006/main"/>
-          <a:ln xmlns:a="http://schemas.openxmlformats.org/drawingml/2006/main" w="0">
-            <a:noFill/>
-          </a:ln>
-        </p:spPr>
-        <p:txBody>
-          <a:bodyPr xmlns:a="http://schemas.openxmlformats.org/drawingml/2006/main" wrap="square" lIns="0" tIns="0" rIns="0" bIns="0" anchor="t">
-            <a:noAutofit/>
-          </a:bodyPr>
-          <a:lstStyle xmlns:a="http://schemas.openxmlformats.org/drawingml/2006/main"/>
-          <a:p xmlns:a="http://schemas.openxmlformats.org/drawingml/2006/main">
-            <a:pPr algn="l">
-              <a:lnSpc>
-                <a:spcPct val="120000"/>
-              </a:lnSpc>
-              <a:buNone/>
-              <a:defRPr sz="1725" b="0">
+            <a:off x="533400" y="5524500"/>
+            <a:ext cx="5219700" cy="457200"/>
+          </a:xfrm>
+          <a:prstGeom xmlns:a="http://schemas.openxmlformats.org/drawingml/2006/main" prst="rect">
+            <a:avLst/>
+          </a:prstGeom>
+          <a:noFill xmlns:a="http://schemas.openxmlformats.org/drawingml/2006/main"/>
+          <a:ln xmlns:a="http://schemas.openxmlformats.org/drawingml/2006/main" w="0">
+            <a:noFill/>
+          </a:ln>
+        </p:spPr>
+        <p:txBody>
+          <a:bodyPr xmlns:a="http://schemas.openxmlformats.org/drawingml/2006/main" wrap="square" lIns="0" tIns="0" rIns="0" bIns="0" anchor="t">
+            <a:noAutofit/>
+          </a:bodyPr>
+          <a:lstStyle xmlns:a="http://schemas.openxmlformats.org/drawingml/2006/main"/>
+          <a:p xmlns:a="http://schemas.openxmlformats.org/drawingml/2006/main">
+            <a:pPr algn="l">
+              <a:lnSpc>
+                <a:spcPct val="120000"/>
+              </a:lnSpc>
+              <a:buNone/>
+              <a:defRPr sz="1350" b="0">
                 <a:solidFill>
                   <a:srgbClr val="566C7E"/>
                 </a:solidFill>
@@ -13336,25 +13335,25 @@
               </a:defRPr>
             </a:pPr>
             <a:r>
-              <a:rPr sz="1725" b="0">
+              <a:rPr sz="1350" b="0">
                 <a:solidFill>
                   <a:srgbClr val="566C7E"/>
                 </a:solidFill>
                 <a:latin typeface="Arial"/>
                 <a:ea typeface="Arial"/>
                 <a:cs typeface="Arial"/>
-                <a:hlinkClick xmlns:r="http://schemas.openxmlformats.org/officeDocument/2006/relationships" r:id="Rbb047d4bfd0e4ae3"/>
-              </a:rPr>
-              <a:t>Guangdong Department</a:t>
-            </a:r>
-          </a:p>
-          <a:p xmlns:a="http://schemas.openxmlformats.org/drawingml/2006/main">
-            <a:pPr algn="l">
-              <a:lnSpc>
-                <a:spcPct val="120000"/>
-              </a:lnSpc>
-              <a:buNone/>
-              <a:defRPr sz="1725" b="0">
+                <a:hlinkClick xmlns:r="http://schemas.openxmlformats.org/officeDocument/2006/relationships" r:id="Rfd0e53e7717e474b"/>
+              </a:rPr>
+              <a:t>Guangdong Department of Education</a:t>
+            </a:r>
+          </a:p>
+          <a:p xmlns:a="http://schemas.openxmlformats.org/drawingml/2006/main">
+            <a:pPr algn="l">
+              <a:lnSpc>
+                <a:spcPct val="120000"/>
+              </a:lnSpc>
+              <a:buNone/>
+              <a:defRPr sz="1350" b="0">
                 <a:solidFill>
                   <a:srgbClr val="566C7E"/>
                 </a:solidFill>
@@ -13364,25 +13363,120 @@
               </a:defRPr>
             </a:pPr>
             <a:r>
-              <a:rPr sz="1725" b="0">
+              <a:rPr sz="1350" b="0">
                 <a:solidFill>
                   <a:srgbClr val="566C7E"/>
                 </a:solidFill>
                 <a:latin typeface="Arial"/>
                 <a:ea typeface="Arial"/>
                 <a:cs typeface="Arial"/>
-                <a:hlinkClick xmlns:r="http://schemas.openxmlformats.org/officeDocument/2006/relationships" r:id="R786f1c7d95e249c0"/>
-              </a:rPr>
-              <a:t>of Education · 9 April 2025</a:t>
-            </a:r>
-          </a:p>
-          <a:p xmlns:a="http://schemas.openxmlformats.org/drawingml/2006/main">
-            <a:pPr algn="l">
-              <a:lnSpc>
-                <a:spcPct val="120000"/>
-              </a:lnSpc>
-              <a:buNone/>
-              <a:defRPr sz="1725" b="0">
+                <a:hlinkClick xmlns:r="http://schemas.openxmlformats.org/officeDocument/2006/relationships" r:id="R7ebcae30726c436c"/>
+              </a:rPr>
+              <a:t>9 April 2025 · Trial documents</a:t>
+            </a:r>
+          </a:p>
+        </p:txBody>
+      </p:sp>
+      <p:sp>
+        <p:nvSpPr>
+          <p:cNvPr id="6" name="s4-body-6">
+            <a:extLst xmlns:a="http://schemas.openxmlformats.org/drawingml/2006/main">
+              <a:ext uri="{FF2B5EF4-FFF2-40B4-BE49-F238E27FC236}">
+                <a16:creationId xmlns:a16="http://schemas.microsoft.com/office/drawing/2014/main" id="{91788859-BECD-40B9-97C9-E5CED96AC5FC}"/>
+              </a:ext>
+            </a:extLst>
+          </p:cNvPr>
+          <p:cNvSpPr>
+            <a:spLocks xmlns:a="http://schemas.openxmlformats.org/drawingml/2006/main" noGrp="1"/>
+          </p:cNvSpPr>
+          <p:nvPr/>
+        </p:nvSpPr>
+        <p:spPr>
+          <a:xfrm xmlns:a="http://schemas.openxmlformats.org/drawingml/2006/main">
+            <a:off x="6200775" y="2724150"/>
+            <a:ext cx="5457825" cy="381000"/>
+          </a:xfrm>
+          <a:prstGeom xmlns:a="http://schemas.openxmlformats.org/drawingml/2006/main" prst="rect">
+            <a:avLst/>
+          </a:prstGeom>
+          <a:noFill xmlns:a="http://schemas.openxmlformats.org/drawingml/2006/main"/>
+          <a:ln xmlns:a="http://schemas.openxmlformats.org/drawingml/2006/main" w="0">
+            <a:noFill/>
+          </a:ln>
+        </p:spPr>
+        <p:txBody>
+          <a:bodyPr xmlns:a="http://schemas.openxmlformats.org/drawingml/2006/main" wrap="square" lIns="0" tIns="0" rIns="0" bIns="0" anchor="t">
+            <a:noAutofit/>
+          </a:bodyPr>
+          <a:lstStyle xmlns:a="http://schemas.openxmlformats.org/drawingml/2006/main"/>
+          <a:p xmlns:a="http://schemas.openxmlformats.org/drawingml/2006/main">
+            <a:pPr algn="l">
+              <a:lnSpc>
+                <a:spcPct val="120000"/>
+              </a:lnSpc>
+              <a:buNone/>
+              <a:defRPr sz="2175" b="1">
+                <a:solidFill>
+                  <a:srgbClr val="142D43"/>
+                </a:solidFill>
+                <a:latin typeface="Arial"/>
+                <a:ea typeface="Arial"/>
+                <a:cs typeface="Arial"/>
+              </a:defRPr>
+            </a:pPr>
+            <a:r>
+              <a:rPr sz="2175" b="1">
+                <a:solidFill>
+                  <a:srgbClr val="142D43"/>
+                </a:solidFill>
+                <a:latin typeface="Arial"/>
+                <a:ea typeface="Arial"/>
+                <a:cs typeface="Arial"/>
+              </a:rPr>
+              <a:t>Teacher AI literacy</a:t>
+            </a:r>
+          </a:p>
+        </p:txBody>
+      </p:sp>
+      <p:sp>
+        <p:nvSpPr>
+          <p:cNvPr id="7" name="s4-body-7">
+            <a:extLst xmlns:a="http://schemas.openxmlformats.org/drawingml/2006/main">
+              <a:ext uri="{FF2B5EF4-FFF2-40B4-BE49-F238E27FC236}">
+                <a16:creationId xmlns:a16="http://schemas.microsoft.com/office/drawing/2014/main" id="{7001B6F6-4B33-48C5-B9F0-06A7E01A95ED}"/>
+              </a:ext>
+            </a:extLst>
+          </p:cNvPr>
+          <p:cNvSpPr>
+            <a:spLocks xmlns:a="http://schemas.openxmlformats.org/drawingml/2006/main" noGrp="1"/>
+          </p:cNvSpPr>
+          <p:nvPr/>
+        </p:nvSpPr>
+        <p:spPr>
+          <a:xfrm xmlns:a="http://schemas.openxmlformats.org/drawingml/2006/main">
+            <a:off x="6200775" y="3105150"/>
+            <a:ext cx="5457825" cy="638175"/>
+          </a:xfrm>
+          <a:prstGeom xmlns:a="http://schemas.openxmlformats.org/drawingml/2006/main" prst="rect">
+            <a:avLst/>
+          </a:prstGeom>
+          <a:noFill xmlns:a="http://schemas.openxmlformats.org/drawingml/2006/main"/>
+          <a:ln xmlns:a="http://schemas.openxmlformats.org/drawingml/2006/main" w="0">
+            <a:noFill/>
+          </a:ln>
+        </p:spPr>
+        <p:txBody>
+          <a:bodyPr xmlns:a="http://schemas.openxmlformats.org/drawingml/2006/main" wrap="square" lIns="0" tIns="0" rIns="0" bIns="0" anchor="t">
+            <a:noAutofit/>
+          </a:bodyPr>
+          <a:lstStyle xmlns:a="http://schemas.openxmlformats.org/drawingml/2006/main"/>
+          <a:p xmlns:a="http://schemas.openxmlformats.org/drawingml/2006/main">
+            <a:pPr algn="l">
+              <a:lnSpc>
+                <a:spcPct val="120000"/>
+              </a:lnSpc>
+              <a:buNone/>
+              <a:defRPr sz="1950" b="0">
                 <a:solidFill>
                   <a:srgbClr val="566C7E"/>
                 </a:solidFill>
@@ -13392,38 +13486,37 @@
               </a:defRPr>
             </a:pPr>
             <a:r>
-              <a:rPr sz="1725" b="0">
+              <a:rPr sz="1950" b="0">
                 <a:solidFill>
                   <a:srgbClr val="566C7E"/>
                 </a:solidFill>
                 <a:latin typeface="Arial"/>
                 <a:ea typeface="Arial"/>
                 <a:cs typeface="Arial"/>
-                <a:hlinkClick xmlns:r="http://schemas.openxmlformats.org/officeDocument/2006/relationships" r:id="R4191774192534c4c"/>
-              </a:rPr>
-              <a:t>Trial documents</a:t>
-            </a:r>
-          </a:p>
-        </p:txBody>
-      </p:sp>
-      <p:sp>
-        <p:nvSpPr>
-          <p:cNvPr id="6" name="s4-body-6">
-            <a:extLst xmlns:a="http://schemas.openxmlformats.org/drawingml/2006/main">
-              <a:ext uri="{FF2B5EF4-FFF2-40B4-BE49-F238E27FC236}">
-                <a16:creationId xmlns:a16="http://schemas.microsoft.com/office/drawing/2014/main" id="{91788859-BECD-40B9-97C9-E5CED96AC5FC}"/>
-              </a:ext>
-            </a:extLst>
-          </p:cNvPr>
-          <p:cNvSpPr>
-            <a:spLocks xmlns:a="http://schemas.openxmlformats.org/drawingml/2006/main" noGrp="1"/>
-          </p:cNvSpPr>
-          <p:nvPr/>
-        </p:nvSpPr>
-        <p:spPr>
-          <a:xfrm xmlns:a="http://schemas.openxmlformats.org/drawingml/2006/main">
-            <a:off x="4591050" y="2762250"/>
-            <a:ext cx="6924675" cy="381000"/>
+              </a:rPr>
+              <a:t>Teachers’ knowledge, skills and responsibilities.</a:t>
+            </a:r>
+          </a:p>
+        </p:txBody>
+      </p:sp>
+      <p:sp>
+        <p:nvSpPr>
+          <p:cNvPr id="8" name="s4-body-8">
+            <a:extLst xmlns:a="http://schemas.openxmlformats.org/drawingml/2006/main">
+              <a:ext uri="{FF2B5EF4-FFF2-40B4-BE49-F238E27FC236}">
+                <a16:creationId xmlns:a16="http://schemas.microsoft.com/office/drawing/2014/main" id="{EC2CAD9E-823A-45A8-8135-4F86C01216B9}"/>
+              </a:ext>
+            </a:extLst>
+          </p:cNvPr>
+          <p:cNvSpPr>
+            <a:spLocks xmlns:a="http://schemas.openxmlformats.org/drawingml/2006/main" noGrp="1"/>
+          </p:cNvSpPr>
+          <p:nvPr/>
+        </p:nvSpPr>
+        <p:spPr>
+          <a:xfrm xmlns:a="http://schemas.openxmlformats.org/drawingml/2006/main">
+            <a:off x="6200775" y="3781425"/>
+            <a:ext cx="5457825" cy="381000"/>
           </a:xfrm>
           <a:prstGeom xmlns:a="http://schemas.openxmlformats.org/drawingml/2006/main" prst="rect">
             <a:avLst/>
@@ -13462,29 +13555,29 @@
                 <a:ea typeface="Arial"/>
                 <a:cs typeface="Arial"/>
               </a:rPr>
-              <a:t>Teacher AI literacy</a:t>
-            </a:r>
-          </a:p>
-        </p:txBody>
-      </p:sp>
-      <p:sp>
-        <p:nvSpPr>
-          <p:cNvPr id="7" name="s4-body-7">
-            <a:extLst xmlns:a="http://schemas.openxmlformats.org/drawingml/2006/main">
-              <a:ext uri="{FF2B5EF4-FFF2-40B4-BE49-F238E27FC236}">
-                <a16:creationId xmlns:a16="http://schemas.microsoft.com/office/drawing/2014/main" id="{7001B6F6-4B33-48C5-B9F0-06A7E01A95ED}"/>
-              </a:ext>
-            </a:extLst>
-          </p:cNvPr>
-          <p:cNvSpPr>
-            <a:spLocks xmlns:a="http://schemas.openxmlformats.org/drawingml/2006/main" noGrp="1"/>
-          </p:cNvSpPr>
-          <p:nvPr/>
-        </p:nvSpPr>
-        <p:spPr>
-          <a:xfrm xmlns:a="http://schemas.openxmlformats.org/drawingml/2006/main">
-            <a:off x="4591050" y="3143250"/>
-            <a:ext cx="6924675" cy="619125"/>
+              <a:t>Student AI literacy</a:t>
+            </a:r>
+          </a:p>
+        </p:txBody>
+      </p:sp>
+      <p:sp>
+        <p:nvSpPr>
+          <p:cNvPr id="9" name="s4-body-9">
+            <a:extLst xmlns:a="http://schemas.openxmlformats.org/drawingml/2006/main">
+              <a:ext uri="{FF2B5EF4-FFF2-40B4-BE49-F238E27FC236}">
+                <a16:creationId xmlns:a16="http://schemas.microsoft.com/office/drawing/2014/main" id="{215148AF-8AA2-4A1A-A5C9-7A3298ED5C76}"/>
+              </a:ext>
+            </a:extLst>
+          </p:cNvPr>
+          <p:cNvSpPr>
+            <a:spLocks xmlns:a="http://schemas.openxmlformats.org/drawingml/2006/main" noGrp="1"/>
+          </p:cNvSpPr>
+          <p:nvPr/>
+        </p:nvSpPr>
+        <p:spPr>
+          <a:xfrm xmlns:a="http://schemas.openxmlformats.org/drawingml/2006/main">
+            <a:off x="6200775" y="4162425"/>
+            <a:ext cx="5457825" cy="638175"/>
           </a:xfrm>
           <a:prstGeom xmlns:a="http://schemas.openxmlformats.org/drawingml/2006/main" prst="rect">
             <a:avLst/>
@@ -13523,29 +13616,29 @@
                 <a:ea typeface="Arial"/>
                 <a:cs typeface="Arial"/>
               </a:rPr>
-              <a:t>Teachers’ knowledge, skills and responsibilities.</a:t>
-            </a:r>
-          </a:p>
-        </p:txBody>
-      </p:sp>
-      <p:sp>
-        <p:nvSpPr>
-          <p:cNvPr id="8" name="s4-body-8">
-            <a:extLst xmlns:a="http://schemas.openxmlformats.org/drawingml/2006/main">
-              <a:ext uri="{FF2B5EF4-FFF2-40B4-BE49-F238E27FC236}">
-                <a16:creationId xmlns:a16="http://schemas.microsoft.com/office/drawing/2014/main" id="{EC2CAD9E-823A-45A8-8135-4F86C01216B9}"/>
-              </a:ext>
-            </a:extLst>
-          </p:cNvPr>
-          <p:cNvSpPr>
-            <a:spLocks xmlns:a="http://schemas.openxmlformats.org/drawingml/2006/main" noGrp="1"/>
-          </p:cNvSpPr>
-          <p:nvPr/>
-        </p:nvSpPr>
-        <p:spPr>
-          <a:xfrm xmlns:a="http://schemas.openxmlformats.org/drawingml/2006/main">
-            <a:off x="4591050" y="3781425"/>
-            <a:ext cx="6924675" cy="381000"/>
+              <a:t>Understand and use AI with care and good judgment.</a:t>
+            </a:r>
+          </a:p>
+        </p:txBody>
+      </p:sp>
+      <p:sp>
+        <p:nvSpPr>
+          <p:cNvPr id="10" name="s4-body-10">
+            <a:extLst xmlns:a="http://schemas.openxmlformats.org/drawingml/2006/main">
+              <a:ext uri="{FF2B5EF4-FFF2-40B4-BE49-F238E27FC236}">
+                <a16:creationId xmlns:a16="http://schemas.microsoft.com/office/drawing/2014/main" id="{49A1E8AB-12E2-4985-8157-0286CE2545B5}"/>
+              </a:ext>
+            </a:extLst>
+          </p:cNvPr>
+          <p:cNvSpPr>
+            <a:spLocks xmlns:a="http://schemas.openxmlformats.org/drawingml/2006/main" noGrp="1"/>
+          </p:cNvSpPr>
+          <p:nvPr/>
+        </p:nvSpPr>
+        <p:spPr>
+          <a:xfrm xmlns:a="http://schemas.openxmlformats.org/drawingml/2006/main">
+            <a:off x="6200775" y="4838700"/>
+            <a:ext cx="5457825" cy="381000"/>
           </a:xfrm>
           <a:prstGeom xmlns:a="http://schemas.openxmlformats.org/drawingml/2006/main" prst="rect">
             <a:avLst/>
@@ -13584,128 +13677,6 @@
                 <a:ea typeface="Arial"/>
                 <a:cs typeface="Arial"/>
               </a:rPr>
-              <a:t>Student AI literacy</a:t>
-            </a:r>
-          </a:p>
-        </p:txBody>
-      </p:sp>
-      <p:sp>
-        <p:nvSpPr>
-          <p:cNvPr id="9" name="s4-body-9">
-            <a:extLst xmlns:a="http://schemas.openxmlformats.org/drawingml/2006/main">
-              <a:ext uri="{FF2B5EF4-FFF2-40B4-BE49-F238E27FC236}">
-                <a16:creationId xmlns:a16="http://schemas.microsoft.com/office/drawing/2014/main" id="{215148AF-8AA2-4A1A-A5C9-7A3298ED5C76}"/>
-              </a:ext>
-            </a:extLst>
-          </p:cNvPr>
-          <p:cNvSpPr>
-            <a:spLocks xmlns:a="http://schemas.openxmlformats.org/drawingml/2006/main" noGrp="1"/>
-          </p:cNvSpPr>
-          <p:nvPr/>
-        </p:nvSpPr>
-        <p:spPr>
-          <a:xfrm xmlns:a="http://schemas.openxmlformats.org/drawingml/2006/main">
-            <a:off x="4591050" y="4162425"/>
-            <a:ext cx="6924675" cy="619125"/>
-          </a:xfrm>
-          <a:prstGeom xmlns:a="http://schemas.openxmlformats.org/drawingml/2006/main" prst="rect">
-            <a:avLst/>
-          </a:prstGeom>
-          <a:noFill xmlns:a="http://schemas.openxmlformats.org/drawingml/2006/main"/>
-          <a:ln xmlns:a="http://schemas.openxmlformats.org/drawingml/2006/main" w="0">
-            <a:noFill/>
-          </a:ln>
-        </p:spPr>
-        <p:txBody>
-          <a:bodyPr xmlns:a="http://schemas.openxmlformats.org/drawingml/2006/main" wrap="square" lIns="0" tIns="0" rIns="0" bIns="0" anchor="t">
-            <a:noAutofit/>
-          </a:bodyPr>
-          <a:lstStyle xmlns:a="http://schemas.openxmlformats.org/drawingml/2006/main"/>
-          <a:p xmlns:a="http://schemas.openxmlformats.org/drawingml/2006/main">
-            <a:pPr algn="l">
-              <a:lnSpc>
-                <a:spcPct val="120000"/>
-              </a:lnSpc>
-              <a:buNone/>
-              <a:defRPr sz="1950" b="0">
-                <a:solidFill>
-                  <a:srgbClr val="566C7E"/>
-                </a:solidFill>
-                <a:latin typeface="Arial"/>
-                <a:ea typeface="Arial"/>
-                <a:cs typeface="Arial"/>
-              </a:defRPr>
-            </a:pPr>
-            <a:r>
-              <a:rPr sz="1950" b="0">
-                <a:solidFill>
-                  <a:srgbClr val="566C7E"/>
-                </a:solidFill>
-                <a:latin typeface="Arial"/>
-                <a:ea typeface="Arial"/>
-                <a:cs typeface="Arial"/>
-              </a:rPr>
-              <a:t>Understand and use AI with care and good judgment.</a:t>
-            </a:r>
-          </a:p>
-        </p:txBody>
-      </p:sp>
-      <p:sp>
-        <p:nvSpPr>
-          <p:cNvPr id="10" name="s4-body-10">
-            <a:extLst xmlns:a="http://schemas.openxmlformats.org/drawingml/2006/main">
-              <a:ext uri="{FF2B5EF4-FFF2-40B4-BE49-F238E27FC236}">
-                <a16:creationId xmlns:a16="http://schemas.microsoft.com/office/drawing/2014/main" id="{49A1E8AB-12E2-4985-8157-0286CE2545B5}"/>
-              </a:ext>
-            </a:extLst>
-          </p:cNvPr>
-          <p:cNvSpPr>
-            <a:spLocks xmlns:a="http://schemas.openxmlformats.org/drawingml/2006/main" noGrp="1"/>
-          </p:cNvSpPr>
-          <p:nvPr/>
-        </p:nvSpPr>
-        <p:spPr>
-          <a:xfrm xmlns:a="http://schemas.openxmlformats.org/drawingml/2006/main">
-            <a:off x="4591050" y="4800600"/>
-            <a:ext cx="6924675" cy="381000"/>
-          </a:xfrm>
-          <a:prstGeom xmlns:a="http://schemas.openxmlformats.org/drawingml/2006/main" prst="rect">
-            <a:avLst/>
-          </a:prstGeom>
-          <a:noFill xmlns:a="http://schemas.openxmlformats.org/drawingml/2006/main"/>
-          <a:ln xmlns:a="http://schemas.openxmlformats.org/drawingml/2006/main" w="0">
-            <a:noFill/>
-          </a:ln>
-        </p:spPr>
-        <p:txBody>
-          <a:bodyPr xmlns:a="http://schemas.openxmlformats.org/drawingml/2006/main" wrap="square" lIns="0" tIns="0" rIns="0" bIns="0" anchor="t">
-            <a:noAutofit/>
-          </a:bodyPr>
-          <a:lstStyle xmlns:a="http://schemas.openxmlformats.org/drawingml/2006/main"/>
-          <a:p xmlns:a="http://schemas.openxmlformats.org/drawingml/2006/main">
-            <a:pPr algn="l">
-              <a:lnSpc>
-                <a:spcPct val="120000"/>
-              </a:lnSpc>
-              <a:buNone/>
-              <a:defRPr sz="2175" b="1">
-                <a:solidFill>
-                  <a:srgbClr val="142D43"/>
-                </a:solidFill>
-                <a:latin typeface="Arial"/>
-                <a:ea typeface="Arial"/>
-                <a:cs typeface="Arial"/>
-              </a:defRPr>
-            </a:pPr>
-            <a:r>
-              <a:rPr sz="2175" b="1">
-                <a:solidFill>
-                  <a:srgbClr val="142D43"/>
-                </a:solidFill>
-                <a:latin typeface="Arial"/>
-                <a:ea typeface="Arial"/>
-                <a:cs typeface="Arial"/>
-              </a:rPr>
               <a:t>AI curriculum outline</a:t>
             </a:r>
           </a:p>
@@ -13727,8 +13698,8 @@
         </p:nvSpPr>
         <p:spPr>
           <a:xfrm xmlns:a="http://schemas.openxmlformats.org/drawingml/2006/main">
-            <a:off x="4591050" y="5181600"/>
-            <a:ext cx="6924675" cy="619125"/>
+            <a:off x="6200775" y="5219700"/>
+            <a:ext cx="5457825" cy="638175"/>
           </a:xfrm>
           <a:prstGeom xmlns:a="http://schemas.openxmlformats.org/drawingml/2006/main" prst="rect">
             <a:avLst/>
@@ -13985,6 +13956,28 @@
           </a:p>
         </p:txBody>
       </p:sp>
+      <p:pic>
+        <p:nvPicPr>
+          <p:cNvPr id="33" name=""/>
+          <p:cNvPicPr>
+            <a:picLocks xmlns:a="http://schemas.openxmlformats.org/drawingml/2006/main" noChangeAspect="1"/>
+          </p:cNvPicPr>
+          <p:nvPr/>
+        </p:nvPicPr>
+        <p:blipFill>
+          <a:blip xmlns:r="http://schemas.openxmlformats.org/officeDocument/2006/relationships" xmlns:a="http://schemas.openxmlformats.org/drawingml/2006/main" r:embed="Rc709387b54af488e"/>
+          <a:stretch xmlns:a="http://schemas.openxmlformats.org/drawingml/2006/main"/>
+        </p:blipFill>
+        <p:spPr>
+          <a:xfrm xmlns:a="http://schemas.openxmlformats.org/drawingml/2006/main">
+            <a:off x="533400" y="3114675"/>
+            <a:ext cx="5219700" cy="2217778"/>
+          </a:xfrm>
+          <a:prstGeom xmlns:a="http://schemas.openxmlformats.org/drawingml/2006/main" prst="rect">
+            <a:avLst/>
+          </a:prstGeom>
+        </p:spPr>
+      </p:pic>
     </p:spTree>
     <p:extLst>
       <p:ext uri="{BB962C8B-B14F-4D97-AF65-F5344CB8AC3E}">
@@ -14416,7 +14409,7 @@
           <p:nvPr/>
         </p:nvPicPr>
         <p:blipFill>
-          <a:blip xmlns:r="http://schemas.openxmlformats.org/officeDocument/2006/relationships" xmlns:a="http://schemas.openxmlformats.org/drawingml/2006/main" r:embed="Rc60d099f9ad044d1"/>
+          <a:blip xmlns:r="http://schemas.openxmlformats.org/officeDocument/2006/relationships" xmlns:a="http://schemas.openxmlformats.org/drawingml/2006/main" r:embed="Rfa9024f0ecf246c3"/>
           <a:srcRect xmlns:a="http://schemas.openxmlformats.org/drawingml/2006/main" l="0" t="0" r="0" b="0"/>
           <a:stretch xmlns:a="http://schemas.openxmlformats.org/drawingml/2006/main"/>
         </p:blipFill>
@@ -14439,7 +14432,7 @@
           <p:nvPr/>
         </p:nvPicPr>
         <p:blipFill>
-          <a:blip xmlns:r="http://schemas.openxmlformats.org/officeDocument/2006/relationships" xmlns:a="http://schemas.openxmlformats.org/drawingml/2006/main" r:embed="R31792611e25742f6"/>
+          <a:blip xmlns:r="http://schemas.openxmlformats.org/officeDocument/2006/relationships" xmlns:a="http://schemas.openxmlformats.org/drawingml/2006/main" r:embed="R7384897b46a84348"/>
           <a:srcRect xmlns:a="http://schemas.openxmlformats.org/drawingml/2006/main" l="0" t="21741" r="0" b="21741"/>
           <a:stretch xmlns:a="http://schemas.openxmlformats.org/drawingml/2006/main">
             <a:fillRect l="0" t="0" r="0" b="0"/>
@@ -15133,7 +15126,7 @@
           <p:nvPr/>
         </p:nvPicPr>
         <p:blipFill>
-          <a:blip xmlns:r="http://schemas.openxmlformats.org/officeDocument/2006/relationships" xmlns:a="http://schemas.openxmlformats.org/drawingml/2006/main" r:embed="Ra9c438d429b94552"/>
+          <a:blip xmlns:r="http://schemas.openxmlformats.org/officeDocument/2006/relationships" xmlns:a="http://schemas.openxmlformats.org/drawingml/2006/main" r:embed="R6129d31271d94b17"/>
           <a:srcRect xmlns:a="http://schemas.openxmlformats.org/drawingml/2006/main" l="0" t="7532" r="0" b="7532"/>
           <a:stretch xmlns:a="http://schemas.openxmlformats.org/drawingml/2006/main">
             <a:fillRect l="0" t="0" r="0" b="0"/>
@@ -15888,7 +15881,7 @@
           <p:nvPr/>
         </p:nvPicPr>
         <p:blipFill>
-          <a:blip xmlns:r="http://schemas.openxmlformats.org/officeDocument/2006/relationships" xmlns:a="http://schemas.openxmlformats.org/drawingml/2006/main" r:embed="Rcd7c65f7977b4d45"/>
+          <a:blip xmlns:r="http://schemas.openxmlformats.org/officeDocument/2006/relationships" xmlns:a="http://schemas.openxmlformats.org/drawingml/2006/main" r:embed="Rb24336ac137d4a5d"/>
           <a:srcRect xmlns:a="http://schemas.openxmlformats.org/drawingml/2006/main" l="4136" t="0" r="4136" b="0"/>
           <a:stretch xmlns:a="http://schemas.openxmlformats.org/drawingml/2006/main">
             <a:fillRect l="0" t="0" r="0" b="0"/>
@@ -16826,7 +16819,7 @@
           <p:nvPr/>
         </p:nvPicPr>
         <p:blipFill>
-          <a:blip xmlns:r="http://schemas.openxmlformats.org/officeDocument/2006/relationships" xmlns:a="http://schemas.openxmlformats.org/drawingml/2006/main" r:embed="R4e52aa31654b4183"/>
+          <a:blip xmlns:r="http://schemas.openxmlformats.org/officeDocument/2006/relationships" xmlns:a="http://schemas.openxmlformats.org/drawingml/2006/main" r:embed="R2ae7667ac7d04c0e"/>
           <a:srcRect xmlns:a="http://schemas.openxmlformats.org/drawingml/2006/main" l="0" t="0" r="0" b="0"/>
           <a:stretch xmlns:a="http://schemas.openxmlformats.org/drawingml/2006/main"/>
         </p:blipFill>
@@ -17423,7 +17416,7 @@
           <p:nvPr/>
         </p:nvPicPr>
         <p:blipFill>
-          <a:blip xmlns:r="http://schemas.openxmlformats.org/officeDocument/2006/relationships" xmlns:a="http://schemas.openxmlformats.org/drawingml/2006/main" r:embed="Rba829253498e46fb"/>
+          <a:blip xmlns:r="http://schemas.openxmlformats.org/officeDocument/2006/relationships" xmlns:a="http://schemas.openxmlformats.org/drawingml/2006/main" r:embed="R6ce216a741474696"/>
           <a:srcRect xmlns:a="http://schemas.openxmlformats.org/drawingml/2006/main" l="0" t="15816" r="0" b="15816"/>
           <a:stretch xmlns:a="http://schemas.openxmlformats.org/drawingml/2006/main">
             <a:fillRect l="0" t="0" r="0" b="0"/>

</xml_diff>

<commit_message>
Add subtle CocoRobo branding to UNESCO body slides
</commit_message>
<xml_diff>
--- a/teacher-agent-creators-10min/downloads/UNESCO_Teacher_AI_Agents_EN.pptx
+++ b/teacher-agent-creators-10min/downloads/UNESCO_Teacher_AI_Agents_EN.pptx
@@ -2,29 +2,29 @@
 <file path=ppt/presentation.xml><?xml version="1.0" encoding="utf-8"?>
 <p:presentation xmlns:p="http://schemas.openxmlformats.org/presentationml/2006/main">
   <p:sldMasterIdLst>
-    <p:sldMasterId xmlns:r="http://schemas.openxmlformats.org/officeDocument/2006/relationships" id="2147483648" r:id="R5e5a5fb2821244a0"/>
+    <p:sldMasterId xmlns:r="http://schemas.openxmlformats.org/officeDocument/2006/relationships" id="2147483648" r:id="Rf8ce1fc964df4a3e"/>
   </p:sldMasterIdLst>
   <p:notesMasterIdLst>
-    <p:notesMasterId xmlns:r="http://schemas.openxmlformats.org/officeDocument/2006/relationships" r:id="Reab8ed9f4d874136"/>
+    <p:notesMasterId xmlns:r="http://schemas.openxmlformats.org/officeDocument/2006/relationships" r:id="Rf13710352524449f"/>
   </p:notesMasterIdLst>
   <p:sldIdLst>
-    <p:sldId xmlns:r="http://schemas.openxmlformats.org/officeDocument/2006/relationships" id="256" r:id="Rd693c781e30147ba"/>
-    <p:sldId xmlns:r="http://schemas.openxmlformats.org/officeDocument/2006/relationships" id="257" r:id="Rff75ddf2f5a445bd"/>
-    <p:sldId xmlns:r="http://schemas.openxmlformats.org/officeDocument/2006/relationships" id="258" r:id="Rc1eb07cddbe74244"/>
-    <p:sldId xmlns:r="http://schemas.openxmlformats.org/officeDocument/2006/relationships" id="259" r:id="R59d4f013a5da451e"/>
-    <p:sldId xmlns:r="http://schemas.openxmlformats.org/officeDocument/2006/relationships" id="260" r:id="R438ed5b165194816"/>
-    <p:sldId xmlns:r="http://schemas.openxmlformats.org/officeDocument/2006/relationships" id="261" r:id="Rd0dd79d269e04eb7"/>
-    <p:sldId xmlns:r="http://schemas.openxmlformats.org/officeDocument/2006/relationships" id="262" r:id="R30a17d21ae8b4042"/>
-    <p:sldId xmlns:r="http://schemas.openxmlformats.org/officeDocument/2006/relationships" id="263" r:id="R39d849937d984435"/>
-    <p:sldId xmlns:r="http://schemas.openxmlformats.org/officeDocument/2006/relationships" id="264" r:id="Rc7e71c8fa6da440a"/>
-    <p:sldId xmlns:r="http://schemas.openxmlformats.org/officeDocument/2006/relationships" id="265" r:id="R70b13bd2d1e4468a"/>
-    <p:sldId xmlns:r="http://schemas.openxmlformats.org/officeDocument/2006/relationships" id="266" r:id="Rdec9ef6803d24a68"/>
-    <p:sldId xmlns:r="http://schemas.openxmlformats.org/officeDocument/2006/relationships" id="267" r:id="R97f9faa8830e4763"/>
-    <p:sldId xmlns:r="http://schemas.openxmlformats.org/officeDocument/2006/relationships" id="268" r:id="R3fdd358eb25b4c53"/>
-    <p:sldId xmlns:r="http://schemas.openxmlformats.org/officeDocument/2006/relationships" id="269" r:id="R3812738641c648c0"/>
-    <p:sldId xmlns:r="http://schemas.openxmlformats.org/officeDocument/2006/relationships" id="270" r:id="R490db68999b14d82"/>
-    <p:sldId xmlns:r="http://schemas.openxmlformats.org/officeDocument/2006/relationships" id="271" r:id="Rec05f91c08f043e5"/>
-    <p:sldId xmlns:r="http://schemas.openxmlformats.org/officeDocument/2006/relationships" id="272" r:id="Rd945e029b4454e6e"/>
+    <p:sldId xmlns:r="http://schemas.openxmlformats.org/officeDocument/2006/relationships" id="256" r:id="Rf453c351b00c4e0c"/>
+    <p:sldId xmlns:r="http://schemas.openxmlformats.org/officeDocument/2006/relationships" id="257" r:id="R1b00ecd633554301"/>
+    <p:sldId xmlns:r="http://schemas.openxmlformats.org/officeDocument/2006/relationships" id="258" r:id="Rf7fdcccdf7f24457"/>
+    <p:sldId xmlns:r="http://schemas.openxmlformats.org/officeDocument/2006/relationships" id="259" r:id="Rc78bd0abbbcf4588"/>
+    <p:sldId xmlns:r="http://schemas.openxmlformats.org/officeDocument/2006/relationships" id="260" r:id="R027dff4d4b374591"/>
+    <p:sldId xmlns:r="http://schemas.openxmlformats.org/officeDocument/2006/relationships" id="261" r:id="Rc7ae4ecb8220455d"/>
+    <p:sldId xmlns:r="http://schemas.openxmlformats.org/officeDocument/2006/relationships" id="262" r:id="Ref236005f3a3463d"/>
+    <p:sldId xmlns:r="http://schemas.openxmlformats.org/officeDocument/2006/relationships" id="263" r:id="R4257c7eee3c54e75"/>
+    <p:sldId xmlns:r="http://schemas.openxmlformats.org/officeDocument/2006/relationships" id="264" r:id="R9d28a5a2326047aa"/>
+    <p:sldId xmlns:r="http://schemas.openxmlformats.org/officeDocument/2006/relationships" id="265" r:id="Rb72fc76ad482426b"/>
+    <p:sldId xmlns:r="http://schemas.openxmlformats.org/officeDocument/2006/relationships" id="266" r:id="Rd07ae251796c493e"/>
+    <p:sldId xmlns:r="http://schemas.openxmlformats.org/officeDocument/2006/relationships" id="267" r:id="R655d802bef3045a1"/>
+    <p:sldId xmlns:r="http://schemas.openxmlformats.org/officeDocument/2006/relationships" id="268" r:id="R122328251646430c"/>
+    <p:sldId xmlns:r="http://schemas.openxmlformats.org/officeDocument/2006/relationships" id="269" r:id="Re441362af41f4896"/>
+    <p:sldId xmlns:r="http://schemas.openxmlformats.org/officeDocument/2006/relationships" id="270" r:id="Rdbfacae8f54643eb"/>
+    <p:sldId xmlns:r="http://schemas.openxmlformats.org/officeDocument/2006/relationships" id="271" r:id="R5ca805b2123a4515"/>
+    <p:sldId xmlns:r="http://schemas.openxmlformats.org/officeDocument/2006/relationships" id="272" r:id="R1de25cfde5df4a88"/>
   </p:sldIdLst>
   <p:sldSz cx="12192000" cy="6858000"/>
   <p:notesSz cx="6858000" cy="9144000"/>
@@ -2416,7 +2416,7 @@
   </p:cSld>
   <p:clrMap bg1="lt1" tx1="dk1" bg2="lt2" tx2="dk2" accent1="accent1" accent2="accent2" accent3="accent3" accent4="accent4" accent5="accent5" accent6="accent6" hlink="hlink" folHlink="folHlink"/>
   <p:sldLayoutIdLst>
-    <p:sldLayoutId xmlns:r="http://schemas.openxmlformats.org/officeDocument/2006/relationships" id="2147483649" r:id="Rf24c614b522d4059"/>
+    <p:sldLayoutId xmlns:r="http://schemas.openxmlformats.org/officeDocument/2006/relationships" id="2147483649" r:id="R1076b2e0121d4fb8"/>
   </p:sldLayoutIdLst>
   <p:txStyles>
     <p:titleStyle>
@@ -2971,7 +2971,7 @@
           <p:nvPr/>
         </p:nvPicPr>
         <p:blipFill>
-          <a:blip xmlns:r="http://schemas.openxmlformats.org/officeDocument/2006/relationships" xmlns:a="http://schemas.openxmlformats.org/drawingml/2006/main" r:embed="R602e19df60b14856"/>
+          <a:blip xmlns:r="http://schemas.openxmlformats.org/officeDocument/2006/relationships" xmlns:a="http://schemas.openxmlformats.org/drawingml/2006/main" r:embed="R6c851b5c46ce49e4"/>
           <a:stretch xmlns:a="http://schemas.openxmlformats.org/drawingml/2006/main"/>
         </p:blipFill>
         <p:spPr>
@@ -2993,7 +2993,7 @@
           <p:nvPr/>
         </p:nvPicPr>
         <p:blipFill>
-          <a:blip xmlns:r="http://schemas.openxmlformats.org/officeDocument/2006/relationships" xmlns:a="http://schemas.openxmlformats.org/drawingml/2006/main" r:embed="Rb7d9f53e33f54166"/>
+          <a:blip xmlns:r="http://schemas.openxmlformats.org/officeDocument/2006/relationships" xmlns:a="http://schemas.openxmlformats.org/drawingml/2006/main" r:embed="R3ce70d31e0ab4bee"/>
           <a:srcRect xmlns:a="http://schemas.openxmlformats.org/drawingml/2006/main" l="0" t="0" r="0" b="0"/>
           <a:stretch xmlns:a="http://schemas.openxmlformats.org/drawingml/2006/main"/>
         </p:blipFill>
@@ -3656,7 +3656,7 @@
         <p:spPr>
           <a:xfrm xmlns:a="http://schemas.openxmlformats.org/drawingml/2006/main">
             <a:off x="533400" y="409575"/>
-            <a:ext cx="11125200" cy="238125"/>
+            <a:ext cx="9620250" cy="238125"/>
           </a:xfrm>
           <a:prstGeom xmlns:a="http://schemas.openxmlformats.org/drawingml/2006/main" prst="rect">
             <a:avLst/>
@@ -4853,6 +4853,34 @@
           </a:p>
         </p:txBody>
       </p:sp>
+      <p:pic>
+        <p:nvPicPr>
+          <p:cNvPr id="47" name=""/>
+          <p:cNvPicPr>
+            <a:picLocks xmlns:a="http://schemas.openxmlformats.org/drawingml/2006/main" noChangeAspect="1"/>
+          </p:cNvPicPr>
+          <p:nvPr/>
+        </p:nvPicPr>
+        <p:blipFill>
+          <a:blip xmlns:r="http://schemas.openxmlformats.org/officeDocument/2006/relationships" xmlns:a="http://schemas.openxmlformats.org/drawingml/2006/main" r:embed="R7a8d34051366450f">
+            <a:extLst>
+              <a:ext uri="{96DAC541-7B7A-43D3-8B79-37D633B846F1}">
+                <asvg:svgBlip xmlns:asvg="http://schemas.microsoft.com/office/drawing/2016/SVG/main" r:embed="Re2e7c5bf7ef04274"/>
+              </a:ext>
+            </a:extLst>
+          </a:blip>
+          <a:stretch xmlns:a="http://schemas.openxmlformats.org/drawingml/2006/main"/>
+        </p:blipFill>
+        <p:spPr>
+          <a:xfrm xmlns:a="http://schemas.openxmlformats.org/drawingml/2006/main">
+            <a:off x="10591800" y="447675"/>
+            <a:ext cx="1066800" cy="161925"/>
+          </a:xfrm>
+          <a:prstGeom xmlns:a="http://schemas.openxmlformats.org/drawingml/2006/main" prst="rect">
+            <a:avLst/>
+          </a:prstGeom>
+        </p:spPr>
+      </p:pic>
     </p:spTree>
     <p:extLst>
       <p:ext uri="{BB962C8B-B14F-4D97-AF65-F5344CB8AC3E}">
@@ -4899,7 +4927,7 @@
         <p:spPr>
           <a:xfrm xmlns:a="http://schemas.openxmlformats.org/drawingml/2006/main">
             <a:off x="533400" y="409575"/>
-            <a:ext cx="11125200" cy="238125"/>
+            <a:ext cx="9620250" cy="238125"/>
           </a:xfrm>
           <a:prstGeom xmlns:a="http://schemas.openxmlformats.org/drawingml/2006/main" prst="rect">
             <a:avLst/>
@@ -5338,14 +5366,14 @@
       </p:sp>
       <p:pic>
         <p:nvPicPr>
-          <p:cNvPr id="23" name=""/>
+          <p:cNvPr id="24" name=""/>
           <p:cNvPicPr>
             <a:picLocks xmlns:a="http://schemas.openxmlformats.org/drawingml/2006/main" noChangeAspect="1"/>
           </p:cNvPicPr>
           <p:nvPr/>
         </p:nvPicPr>
         <p:blipFill>
-          <a:blip xmlns:r="http://schemas.openxmlformats.org/officeDocument/2006/relationships" xmlns:a="http://schemas.openxmlformats.org/drawingml/2006/main" r:embed="R830f6c19291d44b3"/>
+          <a:blip xmlns:r="http://schemas.openxmlformats.org/officeDocument/2006/relationships" xmlns:a="http://schemas.openxmlformats.org/drawingml/2006/main" r:embed="R3686368c510f4c25"/>
           <a:srcRect xmlns:a="http://schemas.openxmlformats.org/drawingml/2006/main" l="0" t="0" r="0" b="0"/>
           <a:stretch xmlns:a="http://schemas.openxmlformats.org/drawingml/2006/main"/>
         </p:blipFill>
@@ -5633,6 +5661,34 @@
           </a:p>
         </p:txBody>
       </p:sp>
+      <p:pic>
+        <p:nvPicPr>
+          <p:cNvPr id="30" name=""/>
+          <p:cNvPicPr>
+            <a:picLocks xmlns:a="http://schemas.openxmlformats.org/drawingml/2006/main" noChangeAspect="1"/>
+          </p:cNvPicPr>
+          <p:nvPr/>
+        </p:nvPicPr>
+        <p:blipFill>
+          <a:blip xmlns:r="http://schemas.openxmlformats.org/officeDocument/2006/relationships" xmlns:a="http://schemas.openxmlformats.org/drawingml/2006/main" r:embed="R7484fa65aeeb4c0d">
+            <a:extLst>
+              <a:ext uri="{96DAC541-7B7A-43D3-8B79-37D633B846F1}">
+                <asvg:svgBlip xmlns:asvg="http://schemas.microsoft.com/office/drawing/2016/SVG/main" r:embed="R48bf247440be4454"/>
+              </a:ext>
+            </a:extLst>
+          </a:blip>
+          <a:stretch xmlns:a="http://schemas.openxmlformats.org/drawingml/2006/main"/>
+        </p:blipFill>
+        <p:spPr>
+          <a:xfrm xmlns:a="http://schemas.openxmlformats.org/drawingml/2006/main">
+            <a:off x="10591800" y="447675"/>
+            <a:ext cx="1066800" cy="161925"/>
+          </a:xfrm>
+          <a:prstGeom xmlns:a="http://schemas.openxmlformats.org/drawingml/2006/main" prst="rect">
+            <a:avLst/>
+          </a:prstGeom>
+        </p:spPr>
+      </p:pic>
     </p:spTree>
     <p:extLst>
       <p:ext uri="{BB962C8B-B14F-4D97-AF65-F5344CB8AC3E}">
@@ -5679,7 +5735,7 @@
         <p:spPr>
           <a:xfrm xmlns:a="http://schemas.openxmlformats.org/drawingml/2006/main">
             <a:off x="533400" y="409575"/>
-            <a:ext cx="11125200" cy="238125"/>
+            <a:ext cx="9620250" cy="238125"/>
           </a:xfrm>
           <a:prstGeom xmlns:a="http://schemas.openxmlformats.org/drawingml/2006/main" prst="rect">
             <a:avLst/>
@@ -6057,14 +6113,14 @@
       </p:sp>
       <p:pic>
         <p:nvPicPr>
-          <p:cNvPr id="21" name=""/>
+          <p:cNvPr id="22" name=""/>
           <p:cNvPicPr>
             <a:picLocks xmlns:a="http://schemas.openxmlformats.org/drawingml/2006/main" noChangeAspect="1"/>
           </p:cNvPicPr>
           <p:nvPr/>
         </p:nvPicPr>
         <p:blipFill>
-          <a:blip xmlns:r="http://schemas.openxmlformats.org/officeDocument/2006/relationships" xmlns:a="http://schemas.openxmlformats.org/drawingml/2006/main" r:embed="R960656aa26ad4989"/>
+          <a:blip xmlns:r="http://schemas.openxmlformats.org/officeDocument/2006/relationships" xmlns:a="http://schemas.openxmlformats.org/drawingml/2006/main" r:embed="R617d38a655004b60"/>
           <a:srcRect xmlns:a="http://schemas.openxmlformats.org/drawingml/2006/main" l="7910" t="0" r="7910" b="0"/>
           <a:stretch xmlns:a="http://schemas.openxmlformats.org/drawingml/2006/main">
             <a:fillRect l="0" t="0" r="0" b="0"/>
@@ -6354,6 +6410,34 @@
           </a:p>
         </p:txBody>
       </p:sp>
+      <p:pic>
+        <p:nvPicPr>
+          <p:cNvPr id="28" name=""/>
+          <p:cNvPicPr>
+            <a:picLocks xmlns:a="http://schemas.openxmlformats.org/drawingml/2006/main" noChangeAspect="1"/>
+          </p:cNvPicPr>
+          <p:nvPr/>
+        </p:nvPicPr>
+        <p:blipFill>
+          <a:blip xmlns:r="http://schemas.openxmlformats.org/officeDocument/2006/relationships" xmlns:a="http://schemas.openxmlformats.org/drawingml/2006/main" r:embed="R494bc02e7033432e">
+            <a:extLst>
+              <a:ext uri="{96DAC541-7B7A-43D3-8B79-37D633B846F1}">
+                <asvg:svgBlip xmlns:asvg="http://schemas.microsoft.com/office/drawing/2016/SVG/main" r:embed="R770f3f31c6c3497f"/>
+              </a:ext>
+            </a:extLst>
+          </a:blip>
+          <a:stretch xmlns:a="http://schemas.openxmlformats.org/drawingml/2006/main"/>
+        </p:blipFill>
+        <p:spPr>
+          <a:xfrm xmlns:a="http://schemas.openxmlformats.org/drawingml/2006/main">
+            <a:off x="10591800" y="447675"/>
+            <a:ext cx="1066800" cy="161925"/>
+          </a:xfrm>
+          <a:prstGeom xmlns:a="http://schemas.openxmlformats.org/drawingml/2006/main" prst="rect">
+            <a:avLst/>
+          </a:prstGeom>
+        </p:spPr>
+      </p:pic>
     </p:spTree>
     <p:extLst>
       <p:ext uri="{BB962C8B-B14F-4D97-AF65-F5344CB8AC3E}">
@@ -6400,7 +6484,7 @@
         <p:spPr>
           <a:xfrm xmlns:a="http://schemas.openxmlformats.org/drawingml/2006/main">
             <a:off x="533400" y="409575"/>
-            <a:ext cx="11125200" cy="238125"/>
+            <a:ext cx="9620250" cy="238125"/>
           </a:xfrm>
           <a:prstGeom xmlns:a="http://schemas.openxmlformats.org/drawingml/2006/main" prst="rect">
             <a:avLst/>
@@ -7599,6 +7683,34 @@
           </a:p>
         </p:txBody>
       </p:sp>
+      <p:pic>
+        <p:nvPicPr>
+          <p:cNvPr id="43" name=""/>
+          <p:cNvPicPr>
+            <a:picLocks xmlns:a="http://schemas.openxmlformats.org/drawingml/2006/main" noChangeAspect="1"/>
+          </p:cNvPicPr>
+          <p:nvPr/>
+        </p:nvPicPr>
+        <p:blipFill>
+          <a:blip xmlns:r="http://schemas.openxmlformats.org/officeDocument/2006/relationships" xmlns:a="http://schemas.openxmlformats.org/drawingml/2006/main" r:embed="R079c692cb6e44660">
+            <a:extLst>
+              <a:ext uri="{96DAC541-7B7A-43D3-8B79-37D633B846F1}">
+                <asvg:svgBlip xmlns:asvg="http://schemas.microsoft.com/office/drawing/2016/SVG/main" r:embed="R1a15a408f38e468d"/>
+              </a:ext>
+            </a:extLst>
+          </a:blip>
+          <a:stretch xmlns:a="http://schemas.openxmlformats.org/drawingml/2006/main"/>
+        </p:blipFill>
+        <p:spPr>
+          <a:xfrm xmlns:a="http://schemas.openxmlformats.org/drawingml/2006/main">
+            <a:off x="10591800" y="447675"/>
+            <a:ext cx="1066800" cy="161925"/>
+          </a:xfrm>
+          <a:prstGeom xmlns:a="http://schemas.openxmlformats.org/drawingml/2006/main" prst="rect">
+            <a:avLst/>
+          </a:prstGeom>
+        </p:spPr>
+      </p:pic>
     </p:spTree>
     <p:extLst>
       <p:ext uri="{BB962C8B-B14F-4D97-AF65-F5344CB8AC3E}">
@@ -7645,7 +7757,7 @@
         <p:spPr>
           <a:xfrm xmlns:a="http://schemas.openxmlformats.org/drawingml/2006/main">
             <a:off x="533400" y="409575"/>
-            <a:ext cx="11125200" cy="238125"/>
+            <a:ext cx="9620250" cy="238125"/>
           </a:xfrm>
           <a:prstGeom xmlns:a="http://schemas.openxmlformats.org/drawingml/2006/main" prst="rect">
             <a:avLst/>
@@ -8659,6 +8771,34 @@
           </a:p>
         </p:txBody>
       </p:sp>
+      <p:pic>
+        <p:nvPicPr>
+          <p:cNvPr id="41" name=""/>
+          <p:cNvPicPr>
+            <a:picLocks xmlns:a="http://schemas.openxmlformats.org/drawingml/2006/main" noChangeAspect="1"/>
+          </p:cNvPicPr>
+          <p:nvPr/>
+        </p:nvPicPr>
+        <p:blipFill>
+          <a:blip xmlns:r="http://schemas.openxmlformats.org/officeDocument/2006/relationships" xmlns:a="http://schemas.openxmlformats.org/drawingml/2006/main" r:embed="R56c98508d4a744bd">
+            <a:extLst>
+              <a:ext uri="{96DAC541-7B7A-43D3-8B79-37D633B846F1}">
+                <asvg:svgBlip xmlns:asvg="http://schemas.microsoft.com/office/drawing/2016/SVG/main" r:embed="R4a288810c2b248e5"/>
+              </a:ext>
+            </a:extLst>
+          </a:blip>
+          <a:stretch xmlns:a="http://schemas.openxmlformats.org/drawingml/2006/main"/>
+        </p:blipFill>
+        <p:spPr>
+          <a:xfrm xmlns:a="http://schemas.openxmlformats.org/drawingml/2006/main">
+            <a:off x="10591800" y="447675"/>
+            <a:ext cx="1066800" cy="161925"/>
+          </a:xfrm>
+          <a:prstGeom xmlns:a="http://schemas.openxmlformats.org/drawingml/2006/main" prst="rect">
+            <a:avLst/>
+          </a:prstGeom>
+        </p:spPr>
+      </p:pic>
     </p:spTree>
     <p:extLst>
       <p:ext uri="{BB962C8B-B14F-4D97-AF65-F5344CB8AC3E}">
@@ -8705,7 +8845,7 @@
         <p:spPr>
           <a:xfrm xmlns:a="http://schemas.openxmlformats.org/drawingml/2006/main">
             <a:off x="533400" y="409575"/>
-            <a:ext cx="11125200" cy="238125"/>
+            <a:ext cx="9620250" cy="238125"/>
           </a:xfrm>
           <a:prstGeom xmlns:a="http://schemas.openxmlformats.org/drawingml/2006/main" prst="rect">
             <a:avLst/>
@@ -9660,6 +9800,34 @@
           </a:p>
         </p:txBody>
       </p:sp>
+      <p:pic>
+        <p:nvPicPr>
+          <p:cNvPr id="35" name=""/>
+          <p:cNvPicPr>
+            <a:picLocks xmlns:a="http://schemas.openxmlformats.org/drawingml/2006/main" noChangeAspect="1"/>
+          </p:cNvPicPr>
+          <p:nvPr/>
+        </p:nvPicPr>
+        <p:blipFill>
+          <a:blip xmlns:r="http://schemas.openxmlformats.org/officeDocument/2006/relationships" xmlns:a="http://schemas.openxmlformats.org/drawingml/2006/main" r:embed="Rd95fc65416114e0f">
+            <a:extLst>
+              <a:ext uri="{96DAC541-7B7A-43D3-8B79-37D633B846F1}">
+                <asvg:svgBlip xmlns:asvg="http://schemas.microsoft.com/office/drawing/2016/SVG/main" r:embed="Rc5ab2f86ac134175"/>
+              </a:ext>
+            </a:extLst>
+          </a:blip>
+          <a:stretch xmlns:a="http://schemas.openxmlformats.org/drawingml/2006/main"/>
+        </p:blipFill>
+        <p:spPr>
+          <a:xfrm xmlns:a="http://schemas.openxmlformats.org/drawingml/2006/main">
+            <a:off x="10591800" y="447675"/>
+            <a:ext cx="1066800" cy="161925"/>
+          </a:xfrm>
+          <a:prstGeom xmlns:a="http://schemas.openxmlformats.org/drawingml/2006/main" prst="rect">
+            <a:avLst/>
+          </a:prstGeom>
+        </p:spPr>
+      </p:pic>
     </p:spTree>
     <p:extLst>
       <p:ext uri="{BB962C8B-B14F-4D97-AF65-F5344CB8AC3E}">
@@ -9706,7 +9874,7 @@
         <p:spPr>
           <a:xfrm xmlns:a="http://schemas.openxmlformats.org/drawingml/2006/main">
             <a:off x="533400" y="409575"/>
-            <a:ext cx="11125200" cy="238125"/>
+            <a:ext cx="9620250" cy="238125"/>
           </a:xfrm>
           <a:prstGeom xmlns:a="http://schemas.openxmlformats.org/drawingml/2006/main" prst="rect">
             <a:avLst/>
@@ -10084,14 +10252,14 @@
       </p:sp>
       <p:pic>
         <p:nvPicPr>
-          <p:cNvPr id="21" name=""/>
+          <p:cNvPr id="22" name=""/>
           <p:cNvPicPr>
             <a:picLocks xmlns:a="http://schemas.openxmlformats.org/drawingml/2006/main" noChangeAspect="1"/>
           </p:cNvPicPr>
           <p:nvPr/>
         </p:nvPicPr>
         <p:blipFill>
-          <a:blip xmlns:r="http://schemas.openxmlformats.org/officeDocument/2006/relationships" xmlns:a="http://schemas.openxmlformats.org/drawingml/2006/main" r:embed="R9de25845d22a454f"/>
+          <a:blip xmlns:r="http://schemas.openxmlformats.org/officeDocument/2006/relationships" xmlns:a="http://schemas.openxmlformats.org/drawingml/2006/main" r:embed="R176b82fc8c9c4c66"/>
           <a:stretch xmlns:a="http://schemas.openxmlformats.org/drawingml/2006/main"/>
         </p:blipFill>
         <p:spPr>
@@ -10378,6 +10546,34 @@
           </a:p>
         </p:txBody>
       </p:sp>
+      <p:pic>
+        <p:nvPicPr>
+          <p:cNvPr id="28" name=""/>
+          <p:cNvPicPr>
+            <a:picLocks xmlns:a="http://schemas.openxmlformats.org/drawingml/2006/main" noChangeAspect="1"/>
+          </p:cNvPicPr>
+          <p:nvPr/>
+        </p:nvPicPr>
+        <p:blipFill>
+          <a:blip xmlns:r="http://schemas.openxmlformats.org/officeDocument/2006/relationships" xmlns:a="http://schemas.openxmlformats.org/drawingml/2006/main" r:embed="R96d53434757142fe">
+            <a:extLst>
+              <a:ext uri="{96DAC541-7B7A-43D3-8B79-37D633B846F1}">
+                <asvg:svgBlip xmlns:asvg="http://schemas.microsoft.com/office/drawing/2016/SVG/main" r:embed="R31fe5e280b3b4d08"/>
+              </a:ext>
+            </a:extLst>
+          </a:blip>
+          <a:stretch xmlns:a="http://schemas.openxmlformats.org/drawingml/2006/main"/>
+        </p:blipFill>
+        <p:spPr>
+          <a:xfrm xmlns:a="http://schemas.openxmlformats.org/drawingml/2006/main">
+            <a:off x="10591800" y="447675"/>
+            <a:ext cx="1066800" cy="161925"/>
+          </a:xfrm>
+          <a:prstGeom xmlns:a="http://schemas.openxmlformats.org/drawingml/2006/main" prst="rect">
+            <a:avLst/>
+          </a:prstGeom>
+        </p:spPr>
+      </p:pic>
     </p:spTree>
     <p:extLst>
       <p:ext uri="{BB962C8B-B14F-4D97-AF65-F5344CB8AC3E}">
@@ -10424,7 +10620,7 @@
         <p:spPr>
           <a:xfrm xmlns:a="http://schemas.openxmlformats.org/drawingml/2006/main">
             <a:off x="533400" y="409575"/>
-            <a:ext cx="11125200" cy="238125"/>
+            <a:ext cx="9620250" cy="238125"/>
           </a:xfrm>
           <a:prstGeom xmlns:a="http://schemas.openxmlformats.org/drawingml/2006/main" prst="rect">
             <a:avLst/>
@@ -10707,14 +10903,14 @@
       </p:sp>
       <p:pic>
         <p:nvPicPr>
-          <p:cNvPr id="20" name=""/>
+          <p:cNvPr id="21" name=""/>
           <p:cNvPicPr>
             <a:picLocks xmlns:a="http://schemas.openxmlformats.org/drawingml/2006/main" noChangeAspect="1"/>
           </p:cNvPicPr>
           <p:nvPr/>
         </p:nvPicPr>
         <p:blipFill>
-          <a:blip xmlns:r="http://schemas.openxmlformats.org/officeDocument/2006/relationships" xmlns:a="http://schemas.openxmlformats.org/drawingml/2006/main" r:embed="Rc53853acec824596"/>
+          <a:blip xmlns:r="http://schemas.openxmlformats.org/officeDocument/2006/relationships" xmlns:a="http://schemas.openxmlformats.org/drawingml/2006/main" r:embed="R2be8f45b715c40b2"/>
           <a:srcRect xmlns:a="http://schemas.openxmlformats.org/drawingml/2006/main" l="0" t="0" r="0" b="0"/>
           <a:stretch xmlns:a="http://schemas.openxmlformats.org/drawingml/2006/main"/>
         </p:blipFill>
@@ -10783,7 +10979,7 @@
                 <a:latin typeface="Arial"/>
                 <a:ea typeface="Arial"/>
                 <a:cs typeface="Arial"/>
-                <a:hlinkClick xmlns:r="http://schemas.openxmlformats.org/officeDocument/2006/relationships" r:id="Rb76e0860554e4b56"/>
+                <a:hlinkClick xmlns:r="http://schemas.openxmlformats.org/officeDocument/2006/relationships" r:id="R44a09f85f1ef4450"/>
               </a:rPr>
               <a:t>Online slides ·</a:t>
             </a:r>
@@ -10811,7 +11007,7 @@
                 <a:latin typeface="Arial"/>
                 <a:ea typeface="Arial"/>
                 <a:cs typeface="Arial"/>
-                <a:hlinkClick xmlns:r="http://schemas.openxmlformats.org/officeDocument/2006/relationships" r:id="Rce5c828bce25475c"/>
+                <a:hlinkClick xmlns:r="http://schemas.openxmlformats.org/officeDocument/2006/relationships" r:id="R6c21bafa6ef64441"/>
               </a:rPr>
               <a:t>current version</a:t>
             </a:r>
@@ -10908,14 +11104,14 @@
       </p:sp>
       <p:pic>
         <p:nvPicPr>
-          <p:cNvPr id="23" name=""/>
+          <p:cNvPr id="24" name=""/>
           <p:cNvPicPr>
             <a:picLocks xmlns:a="http://schemas.openxmlformats.org/drawingml/2006/main" noChangeAspect="1"/>
           </p:cNvPicPr>
           <p:nvPr/>
         </p:nvPicPr>
         <p:blipFill>
-          <a:blip xmlns:r="http://schemas.openxmlformats.org/officeDocument/2006/relationships" xmlns:a="http://schemas.openxmlformats.org/drawingml/2006/main" r:embed="Rf8b8311e25794fa3"/>
+          <a:blip xmlns:r="http://schemas.openxmlformats.org/officeDocument/2006/relationships" xmlns:a="http://schemas.openxmlformats.org/drawingml/2006/main" r:embed="Ra7e4d02a7c1d4187"/>
           <a:srcRect xmlns:a="http://schemas.openxmlformats.org/drawingml/2006/main" l="0" t="0" r="0" b="0"/>
           <a:stretch xmlns:a="http://schemas.openxmlformats.org/drawingml/2006/main"/>
         </p:blipFill>
@@ -10984,7 +11180,7 @@
                 <a:latin typeface="Arial"/>
                 <a:ea typeface="Arial"/>
                 <a:cs typeface="Arial"/>
-                <a:hlinkClick xmlns:r="http://schemas.openxmlformats.org/officeDocument/2006/relationships" r:id="Raa4300958e3747c6"/>
+                <a:hlinkClick xmlns:r="http://schemas.openxmlformats.org/officeDocument/2006/relationships" r:id="Rd874f498ea9149b2"/>
               </a:rPr>
               <a:t>UNESCO submission ·</a:t>
             </a:r>
@@ -11012,7 +11208,7 @@
                 <a:latin typeface="Arial"/>
                 <a:ea typeface="Arial"/>
                 <a:cs typeface="Arial"/>
-                <a:hlinkClick xmlns:r="http://schemas.openxmlformats.org/officeDocument/2006/relationships" r:id="Rf15e241885a0414f"/>
+                <a:hlinkClick xmlns:r="http://schemas.openxmlformats.org/officeDocument/2006/relationships" r:id="R82f66ff1c4384671"/>
               </a:rPr>
               <a:t>studies and evidence</a:t>
             </a:r>
@@ -11162,7 +11358,7 @@
                 <a:latin typeface="Arial"/>
                 <a:ea typeface="Arial"/>
                 <a:cs typeface="Arial"/>
-                <a:hlinkClick xmlns:r="http://schemas.openxmlformats.org/officeDocument/2006/relationships" r:id="R8c9bcff218664216"/>
+                <a:hlinkClick xmlns:r="http://schemas.openxmlformats.org/officeDocument/2006/relationships" r:id="Ra598e33f810047a4"/>
               </a:rPr>
               <a:t>tony@cocorobo.cc</a:t>
             </a:r>
@@ -11230,6 +11426,34 @@
           </a:p>
         </p:txBody>
       </p:sp>
+      <p:pic>
+        <p:nvPicPr>
+          <p:cNvPr id="29" name=""/>
+          <p:cNvPicPr>
+            <a:picLocks xmlns:a="http://schemas.openxmlformats.org/drawingml/2006/main" noChangeAspect="1"/>
+          </p:cNvPicPr>
+          <p:nvPr/>
+        </p:nvPicPr>
+        <p:blipFill>
+          <a:blip xmlns:r="http://schemas.openxmlformats.org/officeDocument/2006/relationships" xmlns:a="http://schemas.openxmlformats.org/drawingml/2006/main" r:embed="R90b4e374d2bc46ac">
+            <a:extLst>
+              <a:ext uri="{96DAC541-7B7A-43D3-8B79-37D633B846F1}">
+                <asvg:svgBlip xmlns:asvg="http://schemas.microsoft.com/office/drawing/2016/SVG/main" r:embed="Rbe0e76eff33c4ca9"/>
+              </a:ext>
+            </a:extLst>
+          </a:blip>
+          <a:stretch xmlns:a="http://schemas.openxmlformats.org/drawingml/2006/main"/>
+        </p:blipFill>
+        <p:spPr>
+          <a:xfrm xmlns:a="http://schemas.openxmlformats.org/drawingml/2006/main">
+            <a:off x="10591800" y="447675"/>
+            <a:ext cx="1066800" cy="161925"/>
+          </a:xfrm>
+          <a:prstGeom xmlns:a="http://schemas.openxmlformats.org/drawingml/2006/main" prst="rect">
+            <a:avLst/>
+          </a:prstGeom>
+        </p:spPr>
+      </p:pic>
     </p:spTree>
     <p:extLst>
       <p:ext uri="{BB962C8B-B14F-4D97-AF65-F5344CB8AC3E}">
@@ -11276,7 +11500,7 @@
         <p:spPr>
           <a:xfrm xmlns:a="http://schemas.openxmlformats.org/drawingml/2006/main">
             <a:off x="533400" y="409575"/>
-            <a:ext cx="11125200" cy="238125"/>
+            <a:ext cx="9620250" cy="238125"/>
           </a:xfrm>
           <a:prstGeom xmlns:a="http://schemas.openxmlformats.org/drawingml/2006/main" prst="rect">
             <a:avLst/>
@@ -11871,14 +12095,14 @@
       </p:sp>
       <p:pic>
         <p:nvPicPr>
-          <p:cNvPr id="29" name=""/>
+          <p:cNvPr id="30" name=""/>
           <p:cNvPicPr>
             <a:picLocks xmlns:a="http://schemas.openxmlformats.org/drawingml/2006/main" noChangeAspect="1"/>
           </p:cNvPicPr>
           <p:nvPr/>
         </p:nvPicPr>
         <p:blipFill>
-          <a:blip xmlns:r="http://schemas.openxmlformats.org/officeDocument/2006/relationships" xmlns:a="http://schemas.openxmlformats.org/drawingml/2006/main" r:embed="R2313b2b57815420e"/>
+          <a:blip xmlns:r="http://schemas.openxmlformats.org/officeDocument/2006/relationships" xmlns:a="http://schemas.openxmlformats.org/drawingml/2006/main" r:embed="Rcfd25d1be8714a26"/>
           <a:srcRect xmlns:a="http://schemas.openxmlformats.org/drawingml/2006/main" l="0" t="2370" r="0" b="2370"/>
           <a:stretch xmlns:a="http://schemas.openxmlformats.org/drawingml/2006/main"/>
         </p:blipFill>
@@ -12166,6 +12390,34 @@
           </a:p>
         </p:txBody>
       </p:sp>
+      <p:pic>
+        <p:nvPicPr>
+          <p:cNvPr id="36" name=""/>
+          <p:cNvPicPr>
+            <a:picLocks xmlns:a="http://schemas.openxmlformats.org/drawingml/2006/main" noChangeAspect="1"/>
+          </p:cNvPicPr>
+          <p:nvPr/>
+        </p:nvPicPr>
+        <p:blipFill>
+          <a:blip xmlns:r="http://schemas.openxmlformats.org/officeDocument/2006/relationships" xmlns:a="http://schemas.openxmlformats.org/drawingml/2006/main" r:embed="Rabe2e6b19df3481f">
+            <a:extLst>
+              <a:ext uri="{96DAC541-7B7A-43D3-8B79-37D633B846F1}">
+                <asvg:svgBlip xmlns:asvg="http://schemas.microsoft.com/office/drawing/2016/SVG/main" r:embed="R5dd57d5db32a4c99"/>
+              </a:ext>
+            </a:extLst>
+          </a:blip>
+          <a:stretch xmlns:a="http://schemas.openxmlformats.org/drawingml/2006/main"/>
+        </p:blipFill>
+        <p:spPr>
+          <a:xfrm xmlns:a="http://schemas.openxmlformats.org/drawingml/2006/main">
+            <a:off x="10591800" y="447675"/>
+            <a:ext cx="1066800" cy="161925"/>
+          </a:xfrm>
+          <a:prstGeom xmlns:a="http://schemas.openxmlformats.org/drawingml/2006/main" prst="rect">
+            <a:avLst/>
+          </a:prstGeom>
+        </p:spPr>
+      </p:pic>
     </p:spTree>
     <p:extLst>
       <p:ext uri="{BB962C8B-B14F-4D97-AF65-F5344CB8AC3E}">
@@ -12212,7 +12464,7 @@
         <p:spPr>
           <a:xfrm xmlns:a="http://schemas.openxmlformats.org/drawingml/2006/main">
             <a:off x="533400" y="409575"/>
-            <a:ext cx="11125200" cy="238125"/>
+            <a:ext cx="9620250" cy="238125"/>
           </a:xfrm>
           <a:prstGeom xmlns:a="http://schemas.openxmlformats.org/drawingml/2006/main" prst="rect">
             <a:avLst/>
@@ -12987,6 +13239,34 @@
           </a:p>
         </p:txBody>
       </p:sp>
+      <p:pic>
+        <p:nvPicPr>
+          <p:cNvPr id="31" name=""/>
+          <p:cNvPicPr>
+            <a:picLocks xmlns:a="http://schemas.openxmlformats.org/drawingml/2006/main" noChangeAspect="1"/>
+          </p:cNvPicPr>
+          <p:nvPr/>
+        </p:nvPicPr>
+        <p:blipFill>
+          <a:blip xmlns:r="http://schemas.openxmlformats.org/officeDocument/2006/relationships" xmlns:a="http://schemas.openxmlformats.org/drawingml/2006/main" r:embed="Rd8db574b008e498c">
+            <a:extLst>
+              <a:ext uri="{96DAC541-7B7A-43D3-8B79-37D633B846F1}">
+                <asvg:svgBlip xmlns:asvg="http://schemas.microsoft.com/office/drawing/2016/SVG/main" r:embed="R0ee3208fc0164de4"/>
+              </a:ext>
+            </a:extLst>
+          </a:blip>
+          <a:stretch xmlns:a="http://schemas.openxmlformats.org/drawingml/2006/main"/>
+        </p:blipFill>
+        <p:spPr>
+          <a:xfrm xmlns:a="http://schemas.openxmlformats.org/drawingml/2006/main">
+            <a:off x="10591800" y="447675"/>
+            <a:ext cx="1066800" cy="161925"/>
+          </a:xfrm>
+          <a:prstGeom xmlns:a="http://schemas.openxmlformats.org/drawingml/2006/main" prst="rect">
+            <a:avLst/>
+          </a:prstGeom>
+        </p:spPr>
+      </p:pic>
     </p:spTree>
     <p:extLst>
       <p:ext uri="{BB962C8B-B14F-4D97-AF65-F5344CB8AC3E}">
@@ -13033,7 +13313,7 @@
         <p:spPr>
           <a:xfrm xmlns:a="http://schemas.openxmlformats.org/drawingml/2006/main">
             <a:off x="533400" y="409575"/>
-            <a:ext cx="11125200" cy="238125"/>
+            <a:ext cx="9620250" cy="238125"/>
           </a:xfrm>
           <a:prstGeom xmlns:a="http://schemas.openxmlformats.org/drawingml/2006/main" prst="rect">
             <a:avLst/>
@@ -13342,7 +13622,7 @@
                 <a:latin typeface="Arial"/>
                 <a:ea typeface="Arial"/>
                 <a:cs typeface="Arial"/>
-                <a:hlinkClick xmlns:r="http://schemas.openxmlformats.org/officeDocument/2006/relationships" r:id="Rfd0e53e7717e474b"/>
+                <a:hlinkClick xmlns:r="http://schemas.openxmlformats.org/officeDocument/2006/relationships" r:id="R1db6b992ee5e4e27"/>
               </a:rPr>
               <a:t>Guangdong Department of Education</a:t>
             </a:r>
@@ -13370,7 +13650,7 @@
                 <a:latin typeface="Arial"/>
                 <a:ea typeface="Arial"/>
                 <a:cs typeface="Arial"/>
-                <a:hlinkClick xmlns:r="http://schemas.openxmlformats.org/officeDocument/2006/relationships" r:id="R7ebcae30726c436c"/>
+                <a:hlinkClick xmlns:r="http://schemas.openxmlformats.org/officeDocument/2006/relationships" r:id="Rf7a538469e6b4d0d"/>
               </a:rPr>
               <a:t>9 April 2025 · Trial documents</a:t>
             </a:r>
@@ -13958,20 +14238,48 @@
       </p:sp>
       <p:pic>
         <p:nvPicPr>
-          <p:cNvPr id="33" name=""/>
+          <p:cNvPr id="34" name=""/>
           <p:cNvPicPr>
             <a:picLocks xmlns:a="http://schemas.openxmlformats.org/drawingml/2006/main" noChangeAspect="1"/>
           </p:cNvPicPr>
           <p:nvPr/>
         </p:nvPicPr>
         <p:blipFill>
-          <a:blip xmlns:r="http://schemas.openxmlformats.org/officeDocument/2006/relationships" xmlns:a="http://schemas.openxmlformats.org/drawingml/2006/main" r:embed="Rc709387b54af488e"/>
+          <a:blip xmlns:r="http://schemas.openxmlformats.org/officeDocument/2006/relationships" xmlns:a="http://schemas.openxmlformats.org/drawingml/2006/main" r:embed="R73d1d9e47d314052"/>
           <a:stretch xmlns:a="http://schemas.openxmlformats.org/drawingml/2006/main"/>
         </p:blipFill>
         <p:spPr>
           <a:xfrm xmlns:a="http://schemas.openxmlformats.org/drawingml/2006/main">
             <a:off x="533400" y="3114675"/>
             <a:ext cx="5219700" cy="2217778"/>
+          </a:xfrm>
+          <a:prstGeom xmlns:a="http://schemas.openxmlformats.org/drawingml/2006/main" prst="rect">
+            <a:avLst/>
+          </a:prstGeom>
+        </p:spPr>
+      </p:pic>
+      <p:pic>
+        <p:nvPicPr>
+          <p:cNvPr id="35" name=""/>
+          <p:cNvPicPr>
+            <a:picLocks xmlns:a="http://schemas.openxmlformats.org/drawingml/2006/main" noChangeAspect="1"/>
+          </p:cNvPicPr>
+          <p:nvPr/>
+        </p:nvPicPr>
+        <p:blipFill>
+          <a:blip xmlns:r="http://schemas.openxmlformats.org/officeDocument/2006/relationships" xmlns:a="http://schemas.openxmlformats.org/drawingml/2006/main" r:embed="Rebf634d3988243d1">
+            <a:extLst>
+              <a:ext uri="{96DAC541-7B7A-43D3-8B79-37D633B846F1}">
+                <asvg:svgBlip xmlns:asvg="http://schemas.microsoft.com/office/drawing/2016/SVG/main" r:embed="R2fad9b43ccb04718"/>
+              </a:ext>
+            </a:extLst>
+          </a:blip>
+          <a:stretch xmlns:a="http://schemas.openxmlformats.org/drawingml/2006/main"/>
+        </p:blipFill>
+        <p:spPr>
+          <a:xfrm xmlns:a="http://schemas.openxmlformats.org/drawingml/2006/main">
+            <a:off x="10591800" y="447675"/>
+            <a:ext cx="1066800" cy="161925"/>
           </a:xfrm>
           <a:prstGeom xmlns:a="http://schemas.openxmlformats.org/drawingml/2006/main" prst="rect">
             <a:avLst/>
@@ -14024,7 +14332,7 @@
         <p:spPr>
           <a:xfrm xmlns:a="http://schemas.openxmlformats.org/drawingml/2006/main">
             <a:off x="533400" y="409575"/>
-            <a:ext cx="11125200" cy="238125"/>
+            <a:ext cx="9620250" cy="238125"/>
           </a:xfrm>
           <a:prstGeom xmlns:a="http://schemas.openxmlformats.org/drawingml/2006/main" prst="rect">
             <a:avLst/>
@@ -14400,29 +14708,6 @@
           </a:p>
         </p:txBody>
       </p:sp>
-      <p:pic>
-        <p:nvPicPr>
-          <p:cNvPr id="23" name=""/>
-          <p:cNvPicPr>
-            <a:picLocks xmlns:a="http://schemas.openxmlformats.org/drawingml/2006/main" noChangeAspect="1"/>
-          </p:cNvPicPr>
-          <p:nvPr/>
-        </p:nvPicPr>
-        <p:blipFill>
-          <a:blip xmlns:r="http://schemas.openxmlformats.org/officeDocument/2006/relationships" xmlns:a="http://schemas.openxmlformats.org/drawingml/2006/main" r:embed="Rfa9024f0ecf246c3"/>
-          <a:srcRect xmlns:a="http://schemas.openxmlformats.org/drawingml/2006/main" l="0" t="0" r="0" b="0"/>
-          <a:stretch xmlns:a="http://schemas.openxmlformats.org/drawingml/2006/main"/>
-        </p:blipFill>
-        <p:spPr>
-          <a:xfrm xmlns:a="http://schemas.openxmlformats.org/drawingml/2006/main">
-            <a:off x="7082169" y="1562100"/>
-            <a:ext cx="3837912" cy="2095500"/>
-          </a:xfrm>
-          <a:prstGeom xmlns:a="http://schemas.openxmlformats.org/drawingml/2006/main" prst="rect">
-            <a:avLst/>
-          </a:prstGeom>
-        </p:spPr>
-      </p:pic>
       <p:pic>
         <p:nvPicPr>
           <p:cNvPr id="24" name=""/>
@@ -14432,7 +14717,30 @@
           <p:nvPr/>
         </p:nvPicPr>
         <p:blipFill>
-          <a:blip xmlns:r="http://schemas.openxmlformats.org/officeDocument/2006/relationships" xmlns:a="http://schemas.openxmlformats.org/drawingml/2006/main" r:embed="R7384897b46a84348"/>
+          <a:blip xmlns:r="http://schemas.openxmlformats.org/officeDocument/2006/relationships" xmlns:a="http://schemas.openxmlformats.org/drawingml/2006/main" r:embed="R2a43ad7b20804633"/>
+          <a:srcRect xmlns:a="http://schemas.openxmlformats.org/drawingml/2006/main" l="0" t="0" r="0" b="0"/>
+          <a:stretch xmlns:a="http://schemas.openxmlformats.org/drawingml/2006/main"/>
+        </p:blipFill>
+        <p:spPr>
+          <a:xfrm xmlns:a="http://schemas.openxmlformats.org/drawingml/2006/main">
+            <a:off x="7082169" y="1562100"/>
+            <a:ext cx="3837912" cy="2095500"/>
+          </a:xfrm>
+          <a:prstGeom xmlns:a="http://schemas.openxmlformats.org/drawingml/2006/main" prst="rect">
+            <a:avLst/>
+          </a:prstGeom>
+        </p:spPr>
+      </p:pic>
+      <p:pic>
+        <p:nvPicPr>
+          <p:cNvPr id="25" name=""/>
+          <p:cNvPicPr>
+            <a:picLocks xmlns:a="http://schemas.openxmlformats.org/drawingml/2006/main" noChangeAspect="1"/>
+          </p:cNvPicPr>
+          <p:nvPr/>
+        </p:nvPicPr>
+        <p:blipFill>
+          <a:blip xmlns:r="http://schemas.openxmlformats.org/officeDocument/2006/relationships" xmlns:a="http://schemas.openxmlformats.org/drawingml/2006/main" r:embed="Rc1c4c1c59f4a4692"/>
           <a:srcRect xmlns:a="http://schemas.openxmlformats.org/drawingml/2006/main" l="0" t="21741" r="0" b="21741"/>
           <a:stretch xmlns:a="http://schemas.openxmlformats.org/drawingml/2006/main">
             <a:fillRect l="0" t="0" r="0" b="0"/>
@@ -14722,6 +15030,34 @@
           </a:p>
         </p:txBody>
       </p:sp>
+      <p:pic>
+        <p:nvPicPr>
+          <p:cNvPr id="31" name=""/>
+          <p:cNvPicPr>
+            <a:picLocks xmlns:a="http://schemas.openxmlformats.org/drawingml/2006/main" noChangeAspect="1"/>
+          </p:cNvPicPr>
+          <p:nvPr/>
+        </p:nvPicPr>
+        <p:blipFill>
+          <a:blip xmlns:r="http://schemas.openxmlformats.org/officeDocument/2006/relationships" xmlns:a="http://schemas.openxmlformats.org/drawingml/2006/main" r:embed="R00ae1c24c7d943fb">
+            <a:extLst>
+              <a:ext uri="{96DAC541-7B7A-43D3-8B79-37D633B846F1}">
+                <asvg:svgBlip xmlns:asvg="http://schemas.microsoft.com/office/drawing/2016/SVG/main" r:embed="R904efbbf8dfb4c88"/>
+              </a:ext>
+            </a:extLst>
+          </a:blip>
+          <a:stretch xmlns:a="http://schemas.openxmlformats.org/drawingml/2006/main"/>
+        </p:blipFill>
+        <p:spPr>
+          <a:xfrm xmlns:a="http://schemas.openxmlformats.org/drawingml/2006/main">
+            <a:off x="10591800" y="447675"/>
+            <a:ext cx="1066800" cy="161925"/>
+          </a:xfrm>
+          <a:prstGeom xmlns:a="http://schemas.openxmlformats.org/drawingml/2006/main" prst="rect">
+            <a:avLst/>
+          </a:prstGeom>
+        </p:spPr>
+      </p:pic>
     </p:spTree>
     <p:extLst>
       <p:ext uri="{BB962C8B-B14F-4D97-AF65-F5344CB8AC3E}">
@@ -14768,7 +15104,7 @@
         <p:spPr>
           <a:xfrm xmlns:a="http://schemas.openxmlformats.org/drawingml/2006/main">
             <a:off x="533400" y="409575"/>
-            <a:ext cx="11125200" cy="238125"/>
+            <a:ext cx="9620250" cy="238125"/>
           </a:xfrm>
           <a:prstGeom xmlns:a="http://schemas.openxmlformats.org/drawingml/2006/main" prst="rect">
             <a:avLst/>
@@ -15119,14 +15455,14 @@
       </p:sp>
       <p:pic>
         <p:nvPicPr>
-          <p:cNvPr id="22" name=""/>
+          <p:cNvPr id="23" name=""/>
           <p:cNvPicPr>
             <a:picLocks xmlns:a="http://schemas.openxmlformats.org/drawingml/2006/main" noChangeAspect="1"/>
           </p:cNvPicPr>
           <p:nvPr/>
         </p:nvPicPr>
         <p:blipFill>
-          <a:blip xmlns:r="http://schemas.openxmlformats.org/officeDocument/2006/relationships" xmlns:a="http://schemas.openxmlformats.org/drawingml/2006/main" r:embed="R6129d31271d94b17"/>
+          <a:blip xmlns:r="http://schemas.openxmlformats.org/officeDocument/2006/relationships" xmlns:a="http://schemas.openxmlformats.org/drawingml/2006/main" r:embed="Rc705d8c07e614238"/>
           <a:srcRect xmlns:a="http://schemas.openxmlformats.org/drawingml/2006/main" l="0" t="7532" r="0" b="7532"/>
           <a:stretch xmlns:a="http://schemas.openxmlformats.org/drawingml/2006/main">
             <a:fillRect l="0" t="0" r="0" b="0"/>
@@ -15477,6 +15813,34 @@
           </a:p>
         </p:txBody>
       </p:sp>
+      <p:pic>
+        <p:nvPicPr>
+          <p:cNvPr id="30" name=""/>
+          <p:cNvPicPr>
+            <a:picLocks xmlns:a="http://schemas.openxmlformats.org/drawingml/2006/main" noChangeAspect="1"/>
+          </p:cNvPicPr>
+          <p:nvPr/>
+        </p:nvPicPr>
+        <p:blipFill>
+          <a:blip xmlns:r="http://schemas.openxmlformats.org/officeDocument/2006/relationships" xmlns:a="http://schemas.openxmlformats.org/drawingml/2006/main" r:embed="R9d639fde47154b1a">
+            <a:extLst>
+              <a:ext uri="{96DAC541-7B7A-43D3-8B79-37D633B846F1}">
+                <asvg:svgBlip xmlns:asvg="http://schemas.microsoft.com/office/drawing/2016/SVG/main" r:embed="R78d9c17840cd49bc"/>
+              </a:ext>
+            </a:extLst>
+          </a:blip>
+          <a:stretch xmlns:a="http://schemas.openxmlformats.org/drawingml/2006/main"/>
+        </p:blipFill>
+        <p:spPr>
+          <a:xfrm xmlns:a="http://schemas.openxmlformats.org/drawingml/2006/main">
+            <a:off x="10591800" y="447675"/>
+            <a:ext cx="1066800" cy="161925"/>
+          </a:xfrm>
+          <a:prstGeom xmlns:a="http://schemas.openxmlformats.org/drawingml/2006/main" prst="rect">
+            <a:avLst/>
+          </a:prstGeom>
+        </p:spPr>
+      </p:pic>
     </p:spTree>
     <p:extLst>
       <p:ext uri="{BB962C8B-B14F-4D97-AF65-F5344CB8AC3E}">
@@ -15523,7 +15887,7 @@
         <p:spPr>
           <a:xfrm xmlns:a="http://schemas.openxmlformats.org/drawingml/2006/main">
             <a:off x="533400" y="409575"/>
-            <a:ext cx="11125200" cy="238125"/>
+            <a:ext cx="9620250" cy="238125"/>
           </a:xfrm>
           <a:prstGeom xmlns:a="http://schemas.openxmlformats.org/drawingml/2006/main" prst="rect">
             <a:avLst/>
@@ -15874,14 +16238,14 @@
       </p:sp>
       <p:pic>
         <p:nvPicPr>
-          <p:cNvPr id="21" name=""/>
+          <p:cNvPr id="22" name=""/>
           <p:cNvPicPr>
             <a:picLocks xmlns:a="http://schemas.openxmlformats.org/drawingml/2006/main" noChangeAspect="1"/>
           </p:cNvPicPr>
           <p:nvPr/>
         </p:nvPicPr>
         <p:blipFill>
-          <a:blip xmlns:r="http://schemas.openxmlformats.org/officeDocument/2006/relationships" xmlns:a="http://schemas.openxmlformats.org/drawingml/2006/main" r:embed="Rb24336ac137d4a5d"/>
+          <a:blip xmlns:r="http://schemas.openxmlformats.org/officeDocument/2006/relationships" xmlns:a="http://schemas.openxmlformats.org/drawingml/2006/main" r:embed="R6d3e290b2a9b40a6"/>
           <a:srcRect xmlns:a="http://schemas.openxmlformats.org/drawingml/2006/main" l="4136" t="0" r="4136" b="0"/>
           <a:stretch xmlns:a="http://schemas.openxmlformats.org/drawingml/2006/main">
             <a:fillRect l="0" t="0" r="0" b="0"/>
@@ -16171,6 +16535,34 @@
           </a:p>
         </p:txBody>
       </p:sp>
+      <p:pic>
+        <p:nvPicPr>
+          <p:cNvPr id="28" name=""/>
+          <p:cNvPicPr>
+            <a:picLocks xmlns:a="http://schemas.openxmlformats.org/drawingml/2006/main" noChangeAspect="1"/>
+          </p:cNvPicPr>
+          <p:nvPr/>
+        </p:nvPicPr>
+        <p:blipFill>
+          <a:blip xmlns:r="http://schemas.openxmlformats.org/officeDocument/2006/relationships" xmlns:a="http://schemas.openxmlformats.org/drawingml/2006/main" r:embed="Rb37c0c78cc2047f1">
+            <a:extLst>
+              <a:ext uri="{96DAC541-7B7A-43D3-8B79-37D633B846F1}">
+                <asvg:svgBlip xmlns:asvg="http://schemas.microsoft.com/office/drawing/2016/SVG/main" r:embed="R33dc37cb08554159"/>
+              </a:ext>
+            </a:extLst>
+          </a:blip>
+          <a:stretch xmlns:a="http://schemas.openxmlformats.org/drawingml/2006/main"/>
+        </p:blipFill>
+        <p:spPr>
+          <a:xfrm xmlns:a="http://schemas.openxmlformats.org/drawingml/2006/main">
+            <a:off x="10591800" y="447675"/>
+            <a:ext cx="1066800" cy="161925"/>
+          </a:xfrm>
+          <a:prstGeom xmlns:a="http://schemas.openxmlformats.org/drawingml/2006/main" prst="rect">
+            <a:avLst/>
+          </a:prstGeom>
+        </p:spPr>
+      </p:pic>
     </p:spTree>
     <p:extLst>
       <p:ext uri="{BB962C8B-B14F-4D97-AF65-F5344CB8AC3E}">
@@ -16217,7 +16609,7 @@
         <p:spPr>
           <a:xfrm xmlns:a="http://schemas.openxmlformats.org/drawingml/2006/main">
             <a:off x="533400" y="409575"/>
-            <a:ext cx="11125200" cy="238125"/>
+            <a:ext cx="9620250" cy="238125"/>
           </a:xfrm>
           <a:prstGeom xmlns:a="http://schemas.openxmlformats.org/drawingml/2006/main" prst="rect">
             <a:avLst/>
@@ -16812,14 +17204,14 @@
       </p:sp>
       <p:pic>
         <p:nvPicPr>
-          <p:cNvPr id="30" name=""/>
+          <p:cNvPr id="31" name=""/>
           <p:cNvPicPr>
             <a:picLocks xmlns:a="http://schemas.openxmlformats.org/drawingml/2006/main" noChangeAspect="1"/>
           </p:cNvPicPr>
           <p:nvPr/>
         </p:nvPicPr>
         <p:blipFill>
-          <a:blip xmlns:r="http://schemas.openxmlformats.org/officeDocument/2006/relationships" xmlns:a="http://schemas.openxmlformats.org/drawingml/2006/main" r:embed="R2ae7667ac7d04c0e"/>
+          <a:blip xmlns:r="http://schemas.openxmlformats.org/officeDocument/2006/relationships" xmlns:a="http://schemas.openxmlformats.org/drawingml/2006/main" r:embed="R1b06b283a86045a9"/>
           <a:srcRect xmlns:a="http://schemas.openxmlformats.org/drawingml/2006/main" l="0" t="0" r="0" b="0"/>
           <a:stretch xmlns:a="http://schemas.openxmlformats.org/drawingml/2006/main"/>
         </p:blipFill>
@@ -17168,6 +17560,34 @@
           </a:p>
         </p:txBody>
       </p:sp>
+      <p:pic>
+        <p:nvPicPr>
+          <p:cNvPr id="38" name=""/>
+          <p:cNvPicPr>
+            <a:picLocks xmlns:a="http://schemas.openxmlformats.org/drawingml/2006/main" noChangeAspect="1"/>
+          </p:cNvPicPr>
+          <p:nvPr/>
+        </p:nvPicPr>
+        <p:blipFill>
+          <a:blip xmlns:r="http://schemas.openxmlformats.org/officeDocument/2006/relationships" xmlns:a="http://schemas.openxmlformats.org/drawingml/2006/main" r:embed="Ra14cd6842adb4d1d">
+            <a:extLst>
+              <a:ext uri="{96DAC541-7B7A-43D3-8B79-37D633B846F1}">
+                <asvg:svgBlip xmlns:asvg="http://schemas.microsoft.com/office/drawing/2016/SVG/main" r:embed="Rb196509416e64850"/>
+              </a:ext>
+            </a:extLst>
+          </a:blip>
+          <a:stretch xmlns:a="http://schemas.openxmlformats.org/drawingml/2006/main"/>
+        </p:blipFill>
+        <p:spPr>
+          <a:xfrm xmlns:a="http://schemas.openxmlformats.org/drawingml/2006/main">
+            <a:off x="10591800" y="447675"/>
+            <a:ext cx="1066800" cy="161925"/>
+          </a:xfrm>
+          <a:prstGeom xmlns:a="http://schemas.openxmlformats.org/drawingml/2006/main" prst="rect">
+            <a:avLst/>
+          </a:prstGeom>
+        </p:spPr>
+      </p:pic>
     </p:spTree>
     <p:extLst>
       <p:ext uri="{BB962C8B-B14F-4D97-AF65-F5344CB8AC3E}">
@@ -17214,7 +17634,7 @@
         <p:spPr>
           <a:xfrm xmlns:a="http://schemas.openxmlformats.org/drawingml/2006/main">
             <a:off x="533400" y="409575"/>
-            <a:ext cx="11125200" cy="238125"/>
+            <a:ext cx="9620250" cy="238125"/>
           </a:xfrm>
           <a:prstGeom xmlns:a="http://schemas.openxmlformats.org/drawingml/2006/main" prst="rect">
             <a:avLst/>
@@ -17409,14 +17829,14 @@
       </p:sp>
       <p:pic>
         <p:nvPicPr>
-          <p:cNvPr id="21" name=""/>
+          <p:cNvPr id="22" name=""/>
           <p:cNvPicPr>
             <a:picLocks xmlns:a="http://schemas.openxmlformats.org/drawingml/2006/main" noChangeAspect="1"/>
           </p:cNvPicPr>
           <p:nvPr/>
         </p:nvPicPr>
         <p:blipFill>
-          <a:blip xmlns:r="http://schemas.openxmlformats.org/officeDocument/2006/relationships" xmlns:a="http://schemas.openxmlformats.org/drawingml/2006/main" r:embed="R6ce216a741474696"/>
+          <a:blip xmlns:r="http://schemas.openxmlformats.org/officeDocument/2006/relationships" xmlns:a="http://schemas.openxmlformats.org/drawingml/2006/main" r:embed="R86a10b8305d145a0"/>
           <a:srcRect xmlns:a="http://schemas.openxmlformats.org/drawingml/2006/main" l="0" t="15816" r="0" b="15816"/>
           <a:stretch xmlns:a="http://schemas.openxmlformats.org/drawingml/2006/main">
             <a:fillRect l="0" t="0" r="0" b="0"/>
@@ -18072,6 +18492,34 @@
           </a:p>
         </p:txBody>
       </p:sp>
+      <p:pic>
+        <p:nvPicPr>
+          <p:cNvPr id="34" name=""/>
+          <p:cNvPicPr>
+            <a:picLocks xmlns:a="http://schemas.openxmlformats.org/drawingml/2006/main" noChangeAspect="1"/>
+          </p:cNvPicPr>
+          <p:nvPr/>
+        </p:nvPicPr>
+        <p:blipFill>
+          <a:blip xmlns:r="http://schemas.openxmlformats.org/officeDocument/2006/relationships" xmlns:a="http://schemas.openxmlformats.org/drawingml/2006/main" r:embed="R0d30e38da0fa4597">
+            <a:extLst>
+              <a:ext uri="{96DAC541-7B7A-43D3-8B79-37D633B846F1}">
+                <asvg:svgBlip xmlns:asvg="http://schemas.microsoft.com/office/drawing/2016/SVG/main" r:embed="R009b8c5c5d82416f"/>
+              </a:ext>
+            </a:extLst>
+          </a:blip>
+          <a:stretch xmlns:a="http://schemas.openxmlformats.org/drawingml/2006/main"/>
+        </p:blipFill>
+        <p:spPr>
+          <a:xfrm xmlns:a="http://schemas.openxmlformats.org/drawingml/2006/main">
+            <a:off x="10591800" y="447675"/>
+            <a:ext cx="1066800" cy="161925"/>
+          </a:xfrm>
+          <a:prstGeom xmlns:a="http://schemas.openxmlformats.org/drawingml/2006/main" prst="rect">
+            <a:avLst/>
+          </a:prstGeom>
+        </p:spPr>
+      </p:pic>
     </p:spTree>
     <p:extLst>
       <p:ext uri="{BB962C8B-B14F-4D97-AF65-F5344CB8AC3E}">

</xml_diff>